<commit_message>
Add proof screenshots to presentation
</commit_message>
<xml_diff>
--- a/docs/greenops-platform-presentation.pptx
+++ b/docs/greenops-platform-presentation.pptx
@@ -15,6 +15,12 @@
     <p:sldId id="263" r:id="rId9"/>
     <p:sldId id="264" r:id="rId10"/>
     <p:sldId id="265" r:id="rId11"/>
+    <p:sldId id="266" r:id="rId12"/>
+    <p:sldId id="267" r:id="rId13"/>
+    <p:sldId id="268" r:id="rId14"/>
+    <p:sldId id="269" r:id="rId15"/>
+    <p:sldId id="270" r:id="rId16"/>
+    <p:sldId id="271" r:id="rId17"/>
   </p:sldIdLst>
   <p:sldSz cx="12192000" cy="6858000" type="wide"/>
   <p:notesSz cx="6858000" cy="9144000"/>
@@ -142,7 +148,7 @@
         </p:nvSpPr>
         <p:spPr>
           <a:xfrm>
-            <a:off x="600000" y="380000"/>
+            <a:off x="600000" y="320000"/>
             <a:ext cx="10800000" cy="620000"/>
           </a:xfrm>
           <a:prstGeom prst="rect">
@@ -158,14 +164,14 @@
           <a:lstStyle/>
           <a:p>
             <a:r>
-              <a:rPr lang="fr-FR" sz="3800" b="1">
+              <a:rPr lang="fr-FR" sz="3600" b="1">
                 <a:solidFill>
                   <a:srgbClr val="0F172A"/>
                 </a:solidFill>
               </a:rPr>
               <a:t>GreenOps Platform</a:t>
             </a:r>
-            <a:endParaRPr lang="fr-FR" sz="3800"/>
+            <a:endParaRPr lang="fr-FR" sz="3600"/>
           </a:p>
         </p:txBody>
       </p:sp>
@@ -177,30 +183,30 @@
         </p:nvSpPr>
         <p:spPr>
           <a:xfrm>
-            <a:off x="620000" y="1010000"/>
-            <a:ext cx="10300000" cy="420000"/>
-          </a:xfrm>
-          <a:prstGeom prst="rect">
-            <a:avLst/>
-          </a:prstGeom>
-          <a:noFill/>
-          <a:ln>
-            <a:noFill/>
-          </a:ln>
-        </p:spPr>
-        <p:txBody>
-          <a:bodyPr wrap="square" lIns="0" tIns="0" rIns="0" bIns="0"/>
-          <a:lstStyle/>
-          <a:p>
-            <a:r>
-              <a:rPr lang="fr-FR" sz="1900">
+            <a:off x="620000" y="930000"/>
+            <a:ext cx="10300000" cy="360000"/>
+          </a:xfrm>
+          <a:prstGeom prst="rect">
+            <a:avLst/>
+          </a:prstGeom>
+          <a:noFill/>
+          <a:ln>
+            <a:noFill/>
+          </a:ln>
+        </p:spPr>
+        <p:txBody>
+          <a:bodyPr wrap="square" lIns="0" tIns="0" rIns="0" bIns="0"/>
+          <a:lstStyle/>
+          <a:p>
+            <a:r>
+              <a:rPr lang="fr-FR" sz="1700">
                 <a:solidFill>
                   <a:srgbClr val="475569"/>
                 </a:solidFill>
               </a:rPr>
               <a:t>Projet Docker &amp; Kubernetes</a:t>
             </a:r>
-            <a:endParaRPr lang="fr-FR" sz="1900"/>
+            <a:endParaRPr lang="fr-FR" sz="1700"/>
           </a:p>
         </p:txBody>
       </p:sp>
@@ -212,63 +218,63 @@
         </p:nvSpPr>
         <p:spPr>
           <a:xfrm>
-            <a:off x="780000" y="1720000"/>
-            <a:ext cx="10350000" cy="3300000"/>
-          </a:xfrm>
-          <a:prstGeom prst="rect">
-            <a:avLst/>
-          </a:prstGeom>
-          <a:noFill/>
-          <a:ln>
-            <a:noFill/>
-          </a:ln>
-        </p:spPr>
-        <p:txBody>
-          <a:bodyPr wrap="square" lIns="0" tIns="0" rIns="0" bIns="0"/>
-          <a:lstStyle/>
-          <a:p>
-            <a:r>
-              <a:rPr lang="fr-FR" sz="2300">
+            <a:off x="780000" y="1580000"/>
+            <a:ext cx="10350000" cy="3200000"/>
+          </a:xfrm>
+          <a:prstGeom prst="rect">
+            <a:avLst/>
+          </a:prstGeom>
+          <a:noFill/>
+          <a:ln>
+            <a:noFill/>
+          </a:ln>
+        </p:spPr>
+        <p:txBody>
+          <a:bodyPr wrap="square" lIns="0" tIns="0" rIns="0" bIns="0"/>
+          <a:lstStyle/>
+          <a:p>
+            <a:r>
+              <a:rPr lang="fr-FR" sz="2250">
                 <a:solidFill>
                   <a:srgbClr val="1F2937"/>
                 </a:solidFill>
               </a:rPr>
               <a:t>- Plateforme SaaS pedagogique de supervision energetique</a:t>
             </a:r>
-            <a:endParaRPr lang="fr-FR" sz="2300"/>
-          </a:p>
-          <a:p>
-            <a:r>
-              <a:rPr lang="fr-FR" sz="2300">
+            <a:endParaRPr lang="fr-FR" sz="2250"/>
+          </a:p>
+          <a:p>
+            <a:r>
+              <a:rPr lang="fr-FR" sz="2250">
                 <a:solidFill>
                   <a:srgbClr val="1F2937"/>
                 </a:solidFill>
               </a:rPr>
               <a:t>- Application microservices conteneurisee</a:t>
             </a:r>
-            <a:endParaRPr lang="fr-FR" sz="2300"/>
-          </a:p>
-          <a:p>
-            <a:r>
-              <a:rPr lang="fr-FR" sz="2300">
+            <a:endParaRPr lang="fr-FR" sz="2250"/>
+          </a:p>
+          <a:p>
+            <a:r>
+              <a:rPr lang="fr-FR" sz="2250">
                 <a:solidFill>
                   <a:srgbClr val="1F2937"/>
                 </a:solidFill>
               </a:rPr>
               <a:t>- Deploiement Docker Compose puis Kubernetes</a:t>
             </a:r>
-            <a:endParaRPr lang="fr-FR" sz="2300"/>
-          </a:p>
-          <a:p>
-            <a:r>
-              <a:rPr lang="fr-FR" sz="2300">
+            <a:endParaRPr lang="fr-FR" sz="2250"/>
+          </a:p>
+          <a:p>
+            <a:r>
+              <a:rPr lang="fr-FR" sz="2250">
                 <a:solidFill>
                   <a:srgbClr val="1F2937"/>
                 </a:solidFill>
               </a:rPr>
               <a:t>- Supervision avec Prometheus et Grafana</a:t>
             </a:r>
-            <a:endParaRPr lang="fr-FR" sz="2300"/>
+            <a:endParaRPr lang="fr-FR" sz="2250"/>
           </a:p>
         </p:txBody>
       </p:sp>
@@ -281,7 +287,7 @@
         <p:spPr>
           <a:xfrm>
             <a:off x="780000" y="6500000"/>
-            <a:ext cx="8200000" cy="250000"/>
+            <a:ext cx="8800000" cy="250000"/>
           </a:xfrm>
           <a:prstGeom prst="rect">
             <a:avLst/>
@@ -354,6 +360,1262 @@
             <a:avLst/>
           </a:prstGeom>
           <a:solidFill>
+            <a:srgbClr val="F59E0B"/>
+          </a:solidFill>
+          <a:ln w="14000">
+            <a:solidFill>
+              <a:srgbClr val="F59E0B"/>
+            </a:solidFill>
+          </a:ln>
+        </p:spPr>
+        <p:txBody>
+          <a:bodyPr anchor="ctr" wrap="square" lIns="130000" rIns="130000" tIns="50000" bIns="50000"/>
+          <a:lstStyle/>
+        </p:txBody>
+      </p:sp>
+      <p:sp>
+        <p:nvSpPr>
+          <p:cNvPr id="11" name="Title"/>
+          <p:cNvSpPr txBox="1"/>
+          <p:nvPr/>
+        </p:nvSpPr>
+        <p:spPr>
+          <a:xfrm>
+            <a:off x="600000" y="320000"/>
+            <a:ext cx="10800000" cy="620000"/>
+          </a:xfrm>
+          <a:prstGeom prst="rect">
+            <a:avLst/>
+          </a:prstGeom>
+          <a:noFill/>
+          <a:ln>
+            <a:noFill/>
+          </a:ln>
+        </p:spPr>
+        <p:txBody>
+          <a:bodyPr wrap="square" lIns="0" tIns="0" rIns="0" bIns="0"/>
+          <a:lstStyle/>
+          <a:p>
+            <a:r>
+              <a:rPr lang="fr-FR" sz="3600" b="1">
+                <a:solidFill>
+                  <a:srgbClr val="0F172A"/>
+                </a:solidFill>
+              </a:rPr>
+              <a:t>Observabilite</a:t>
+            </a:r>
+            <a:endParaRPr lang="fr-FR" sz="3600"/>
+          </a:p>
+        </p:txBody>
+      </p:sp>
+      <p:sp>
+        <p:nvSpPr>
+          <p:cNvPr id="12" name="Subtitle"/>
+          <p:cNvSpPr txBox="1"/>
+          <p:nvPr/>
+        </p:nvSpPr>
+        <p:spPr>
+          <a:xfrm>
+            <a:off x="620000" y="930000"/>
+            <a:ext cx="10300000" cy="360000"/>
+          </a:xfrm>
+          <a:prstGeom prst="rect">
+            <a:avLst/>
+          </a:prstGeom>
+          <a:noFill/>
+          <a:ln>
+            <a:noFill/>
+          </a:ln>
+        </p:spPr>
+        <p:txBody>
+          <a:bodyPr wrap="square" lIns="0" tIns="0" rIns="0" bIns="0"/>
+          <a:lstStyle/>
+          <a:p>
+            <a:r>
+              <a:rPr lang="fr-FR" sz="1700">
+                <a:solidFill>
+                  <a:srgbClr val="475569"/>
+                </a:solidFill>
+              </a:rPr>
+              <a:t>Prometheus + Grafana</a:t>
+            </a:r>
+            <a:endParaRPr lang="fr-FR" sz="1700"/>
+          </a:p>
+        </p:txBody>
+      </p:sp>
+      <p:sp>
+        <p:nvSpPr>
+          <p:cNvPr id="13" name="Bullets"/>
+          <p:cNvSpPr txBox="1"/>
+          <p:nvPr/>
+        </p:nvSpPr>
+        <p:spPr>
+          <a:xfrm>
+            <a:off x="780000" y="1580000"/>
+            <a:ext cx="10350000" cy="3200000"/>
+          </a:xfrm>
+          <a:prstGeom prst="rect">
+            <a:avLst/>
+          </a:prstGeom>
+          <a:noFill/>
+          <a:ln>
+            <a:noFill/>
+          </a:ln>
+        </p:spPr>
+        <p:txBody>
+          <a:bodyPr wrap="square" lIns="0" tIns="0" rIns="0" bIns="0"/>
+          <a:lstStyle/>
+          <a:p>
+            <a:r>
+              <a:rPr lang="fr-FR" sz="2250">
+                <a:solidFill>
+                  <a:srgbClr val="1F2937"/>
+                </a:solidFill>
+              </a:rPr>
+              <a:t>- Les services exposent des endpoints /metrics</a:t>
+            </a:r>
+            <a:endParaRPr lang="fr-FR" sz="2250"/>
+          </a:p>
+          <a:p>
+            <a:r>
+              <a:rPr lang="fr-FR" sz="2250">
+                <a:solidFill>
+                  <a:srgbClr val="1F2937"/>
+                </a:solidFill>
+              </a:rPr>
+              <a:t>- Prometheus collecte les metriques techniques</a:t>
+            </a:r>
+            <a:endParaRPr lang="fr-FR" sz="2250"/>
+          </a:p>
+          <a:p>
+            <a:r>
+              <a:rPr lang="fr-FR" sz="2250">
+                <a:solidFill>
+                  <a:srgbClr val="1F2937"/>
+                </a:solidFill>
+              </a:rPr>
+              <a:t>- Grafana affiche un dashboard provisionne automatiquement</a:t>
+            </a:r>
+            <a:endParaRPr lang="fr-FR" sz="2250"/>
+          </a:p>
+          <a:p>
+            <a:r>
+              <a:rPr lang="fr-FR" sz="2250">
+                <a:solidFill>
+                  <a:srgbClr val="1F2937"/>
+                </a:solidFill>
+              </a:rPr>
+              <a:t>- La supervision montre l etat et l activite de la plateforme</a:t>
+            </a:r>
+            <a:endParaRPr lang="fr-FR" sz="2250"/>
+          </a:p>
+          <a:p>
+            <a:r>
+              <a:rPr lang="fr-FR" sz="2250">
+                <a:solidFill>
+                  <a:srgbClr val="1F2937"/>
+                </a:solidFill>
+              </a:rPr>
+              <a:t>- Les logs completent le diagnostic</a:t>
+            </a:r>
+            <a:endParaRPr lang="fr-FR" sz="2250"/>
+          </a:p>
+        </p:txBody>
+      </p:sp>
+      <p:sp>
+        <p:nvSpPr>
+          <p:cNvPr id="15" name="Footer"/>
+          <p:cNvSpPr txBox="1"/>
+          <p:nvPr/>
+        </p:nvSpPr>
+        <p:spPr>
+          <a:xfrm>
+            <a:off x="780000" y="6500000"/>
+            <a:ext cx="8800000" cy="250000"/>
+          </a:xfrm>
+          <a:prstGeom prst="rect">
+            <a:avLst/>
+          </a:prstGeom>
+          <a:noFill/>
+          <a:ln>
+            <a:noFill/>
+          </a:ln>
+        </p:spPr>
+        <p:txBody>
+          <a:bodyPr wrap="square" lIns="0" tIns="0" rIns="0" bIns="0"/>
+          <a:lstStyle/>
+          <a:p>
+            <a:r>
+              <a:rPr lang="fr-FR" sz="1250">
+                <a:solidFill>
+                  <a:srgbClr val="64748B"/>
+                </a:solidFill>
+              </a:rPr>
+              <a:t>La plateforme est observable, pas seulement lancee</a:t>
+            </a:r>
+            <a:endParaRPr lang="fr-FR" sz="1250"/>
+          </a:p>
+        </p:txBody>
+      </p:sp>
+    </p:spTree>
+  </p:cSld>
+  <p:clrMapOvr>
+    <a:masterClrMapping/>
+  </p:clrMapOvr>
+</p:sld>
+</file>
+
+<file path=ppt/slides/slide11.xml><?xml version="1.0" encoding="utf-8"?>
+<p:sld xmlns:a="http://schemas.openxmlformats.org/drawingml/2006/main" xmlns:r="http://schemas.openxmlformats.org/officeDocument/2006/relationships" xmlns:p="http://schemas.openxmlformats.org/presentationml/2006/main">
+  <p:cSld>
+    <p:bg>
+      <p:bgPr>
+        <a:solidFill>
+          <a:srgbClr val="F8FAFC"/>
+        </a:solidFill>
+      </p:bgPr>
+    </p:bg>
+    <p:spTree>
+      <p:nvGrpSpPr>
+        <p:cNvPr id="1" name=""/>
+        <p:cNvGrpSpPr/>
+        <p:nvPr/>
+      </p:nvGrpSpPr>
+      <p:grpSpPr>
+        <a:xfrm>
+          <a:off x="0" y="0"/>
+          <a:ext cx="0" cy="0"/>
+          <a:chOff x="0" y="0"/>
+          <a:chExt cx="0" cy="0"/>
+        </a:xfrm>
+      </p:grpSpPr>
+      <p:sp>
+        <p:nvSpPr>
+          <p:cNvPr id="14" name="Accent bar"/>
+          <p:cNvSpPr/>
+          <p:nvPr/>
+        </p:nvSpPr>
+        <p:spPr>
+          <a:xfrm>
+            <a:off x="0" y="0"/>
+            <a:ext cx="12192000" cy="160000"/>
+          </a:xfrm>
+          <a:prstGeom prst="roundRect">
+            <a:avLst/>
+          </a:prstGeom>
+          <a:solidFill>
+            <a:srgbClr val="F59E0B"/>
+          </a:solidFill>
+          <a:ln w="14000">
+            <a:solidFill>
+              <a:srgbClr val="F59E0B"/>
+            </a:solidFill>
+          </a:ln>
+        </p:spPr>
+        <p:txBody>
+          <a:bodyPr anchor="ctr" wrap="square" lIns="130000" rIns="130000" tIns="50000" bIns="50000"/>
+          <a:lstStyle/>
+        </p:txBody>
+      </p:sp>
+      <p:sp>
+        <p:nvSpPr>
+          <p:cNvPr id="11" name="Title"/>
+          <p:cNvSpPr txBox="1"/>
+          <p:nvPr/>
+        </p:nvSpPr>
+        <p:spPr>
+          <a:xfrm>
+            <a:off x="600000" y="320000"/>
+            <a:ext cx="10800000" cy="620000"/>
+          </a:xfrm>
+          <a:prstGeom prst="rect">
+            <a:avLst/>
+          </a:prstGeom>
+          <a:noFill/>
+          <a:ln>
+            <a:noFill/>
+          </a:ln>
+        </p:spPr>
+        <p:txBody>
+          <a:bodyPr wrap="square" lIns="0" tIns="0" rIns="0" bIns="0"/>
+          <a:lstStyle/>
+          <a:p>
+            <a:r>
+              <a:rPr lang="fr-FR" sz="3600" b="1">
+                <a:solidFill>
+                  <a:srgbClr val="0F172A"/>
+                </a:solidFill>
+              </a:rPr>
+              <a:t>Preuve Prometheus</a:t>
+            </a:r>
+            <a:endParaRPr lang="fr-FR" sz="3600"/>
+          </a:p>
+        </p:txBody>
+      </p:sp>
+      <p:sp>
+        <p:nvSpPr>
+          <p:cNvPr id="12" name="Subtitle"/>
+          <p:cNvSpPr txBox="1"/>
+          <p:nvPr/>
+        </p:nvSpPr>
+        <p:spPr>
+          <a:xfrm>
+            <a:off x="620000" y="930000"/>
+            <a:ext cx="10300000" cy="360000"/>
+          </a:xfrm>
+          <a:prstGeom prst="rect">
+            <a:avLst/>
+          </a:prstGeom>
+          <a:noFill/>
+          <a:ln>
+            <a:noFill/>
+          </a:ln>
+        </p:spPr>
+        <p:txBody>
+          <a:bodyPr wrap="square" lIns="0" tIns="0" rIns="0" bIns="0"/>
+          <a:lstStyle/>
+          <a:p>
+            <a:r>
+              <a:rPr lang="fr-FR" sz="1700">
+                <a:solidFill>
+                  <a:srgbClr val="475569"/>
+                </a:solidFill>
+              </a:rPr>
+              <a:t>Targets des services GreenOps en etat UP</a:t>
+            </a:r>
+            <a:endParaRPr lang="fr-FR" sz="1700"/>
+          </a:p>
+        </p:txBody>
+      </p:sp>
+      <p:pic>
+        <p:nvPicPr>
+          <p:cNvPr id="13" name="Proof image"/>
+          <p:cNvPicPr/>
+          <p:nvPr/>
+        </p:nvPicPr>
+        <p:blipFill>
+          <a:blip r:embed="rId2"/>
+          <a:stretch>
+            <a:fillRect/>
+          </a:stretch>
+        </p:blipFill>
+        <p:spPr>
+          <a:xfrm>
+            <a:off x="1650000" y="1400000"/>
+            <a:ext cx="8890000" cy="5000000"/>
+          </a:xfrm>
+          <a:prstGeom prst="rect">
+            <a:avLst/>
+          </a:prstGeom>
+          <a:ln w="18000">
+            <a:solidFill>
+              <a:srgbClr val="CBD5E1"/>
+            </a:solidFill>
+          </a:ln>
+        </p:spPr>
+      </p:pic>
+      <p:sp>
+        <p:nvSpPr>
+          <p:cNvPr id="15" name="Footer"/>
+          <p:cNvSpPr txBox="1"/>
+          <p:nvPr/>
+        </p:nvSpPr>
+        <p:spPr>
+          <a:xfrm>
+            <a:off x="780000" y="6500000"/>
+            <a:ext cx="8800000" cy="250000"/>
+          </a:xfrm>
+          <a:prstGeom prst="rect">
+            <a:avLst/>
+          </a:prstGeom>
+          <a:noFill/>
+          <a:ln>
+            <a:noFill/>
+          </a:ln>
+        </p:spPr>
+        <p:txBody>
+          <a:bodyPr wrap="square" lIns="0" tIns="0" rIns="0" bIns="0"/>
+          <a:lstStyle/>
+          <a:p>
+            <a:r>
+              <a:rPr lang="fr-FR" sz="1250">
+                <a:solidFill>
+                  <a:srgbClr val="64748B"/>
+                </a:solidFill>
+              </a:rPr>
+              <a:t>Capture web : Prometheus Target health</a:t>
+            </a:r>
+            <a:endParaRPr lang="fr-FR" sz="1250"/>
+          </a:p>
+        </p:txBody>
+      </p:sp>
+    </p:spTree>
+  </p:cSld>
+  <p:clrMapOvr>
+    <a:masterClrMapping/>
+  </p:clrMapOvr>
+</p:sld>
+</file>
+
+<file path=ppt/slides/slide12.xml><?xml version="1.0" encoding="utf-8"?>
+<p:sld xmlns:a="http://schemas.openxmlformats.org/drawingml/2006/main" xmlns:r="http://schemas.openxmlformats.org/officeDocument/2006/relationships" xmlns:p="http://schemas.openxmlformats.org/presentationml/2006/main">
+  <p:cSld>
+    <p:bg>
+      <p:bgPr>
+        <a:solidFill>
+          <a:srgbClr val="F8FAFC"/>
+        </a:solidFill>
+      </p:bgPr>
+    </p:bg>
+    <p:spTree>
+      <p:nvGrpSpPr>
+        <p:cNvPr id="1" name=""/>
+        <p:cNvGrpSpPr/>
+        <p:nvPr/>
+      </p:nvGrpSpPr>
+      <p:grpSpPr>
+        <a:xfrm>
+          <a:off x="0" y="0"/>
+          <a:ext cx="0" cy="0"/>
+          <a:chOff x="0" y="0"/>
+          <a:chExt cx="0" cy="0"/>
+        </a:xfrm>
+      </p:grpSpPr>
+      <p:sp>
+        <p:nvSpPr>
+          <p:cNvPr id="14" name="Accent bar"/>
+          <p:cNvSpPr/>
+          <p:nvPr/>
+        </p:nvSpPr>
+        <p:spPr>
+          <a:xfrm>
+            <a:off x="0" y="0"/>
+            <a:ext cx="12192000" cy="160000"/>
+          </a:xfrm>
+          <a:prstGeom prst="roundRect">
+            <a:avLst/>
+          </a:prstGeom>
+          <a:solidFill>
+            <a:srgbClr val="F59E0B"/>
+          </a:solidFill>
+          <a:ln w="14000">
+            <a:solidFill>
+              <a:srgbClr val="F59E0B"/>
+            </a:solidFill>
+          </a:ln>
+        </p:spPr>
+        <p:txBody>
+          <a:bodyPr anchor="ctr" wrap="square" lIns="130000" rIns="130000" tIns="50000" bIns="50000"/>
+          <a:lstStyle/>
+        </p:txBody>
+      </p:sp>
+      <p:sp>
+        <p:nvSpPr>
+          <p:cNvPr id="11" name="Title"/>
+          <p:cNvSpPr txBox="1"/>
+          <p:nvPr/>
+        </p:nvSpPr>
+        <p:spPr>
+          <a:xfrm>
+            <a:off x="600000" y="320000"/>
+            <a:ext cx="10800000" cy="620000"/>
+          </a:xfrm>
+          <a:prstGeom prst="rect">
+            <a:avLst/>
+          </a:prstGeom>
+          <a:noFill/>
+          <a:ln>
+            <a:noFill/>
+          </a:ln>
+        </p:spPr>
+        <p:txBody>
+          <a:bodyPr wrap="square" lIns="0" tIns="0" rIns="0" bIns="0"/>
+          <a:lstStyle/>
+          <a:p>
+            <a:r>
+              <a:rPr lang="fr-FR" sz="3600" b="1">
+                <a:solidFill>
+                  <a:srgbClr val="0F172A"/>
+                </a:solidFill>
+              </a:rPr>
+              <a:t>Preuve Grafana</a:t>
+            </a:r>
+            <a:endParaRPr lang="fr-FR" sz="3600"/>
+          </a:p>
+        </p:txBody>
+      </p:sp>
+      <p:sp>
+        <p:nvSpPr>
+          <p:cNvPr id="12" name="Subtitle"/>
+          <p:cNvSpPr txBox="1"/>
+          <p:nvPr/>
+        </p:nvSpPr>
+        <p:spPr>
+          <a:xfrm>
+            <a:off x="620000" y="930000"/>
+            <a:ext cx="10300000" cy="360000"/>
+          </a:xfrm>
+          <a:prstGeom prst="rect">
+            <a:avLst/>
+          </a:prstGeom>
+          <a:noFill/>
+          <a:ln>
+            <a:noFill/>
+          </a:ln>
+        </p:spPr>
+        <p:txBody>
+          <a:bodyPr wrap="square" lIns="0" tIns="0" rIns="0" bIns="0"/>
+          <a:lstStyle/>
+          <a:p>
+            <a:r>
+              <a:rPr lang="fr-FR" sz="1700">
+                <a:solidFill>
+                  <a:srgbClr val="475569"/>
+                </a:solidFill>
+              </a:rPr>
+              <a:t>Interface Grafana accessible sur le port 3001</a:t>
+            </a:r>
+            <a:endParaRPr lang="fr-FR" sz="1700"/>
+          </a:p>
+        </p:txBody>
+      </p:sp>
+      <p:pic>
+        <p:nvPicPr>
+          <p:cNvPr id="13" name="Proof image"/>
+          <p:cNvPicPr/>
+          <p:nvPr/>
+        </p:nvPicPr>
+        <p:blipFill>
+          <a:blip r:embed="rId2"/>
+          <a:stretch>
+            <a:fillRect/>
+          </a:stretch>
+        </p:blipFill>
+        <p:spPr>
+          <a:xfrm>
+            <a:off x="1650000" y="1400000"/>
+            <a:ext cx="8890000" cy="5000000"/>
+          </a:xfrm>
+          <a:prstGeom prst="rect">
+            <a:avLst/>
+          </a:prstGeom>
+          <a:ln w="18000">
+            <a:solidFill>
+              <a:srgbClr val="CBD5E1"/>
+            </a:solidFill>
+          </a:ln>
+        </p:spPr>
+      </p:pic>
+      <p:sp>
+        <p:nvSpPr>
+          <p:cNvPr id="15" name="Footer"/>
+          <p:cNvSpPr txBox="1"/>
+          <p:nvPr/>
+        </p:nvSpPr>
+        <p:spPr>
+          <a:xfrm>
+            <a:off x="780000" y="6500000"/>
+            <a:ext cx="8800000" cy="250000"/>
+          </a:xfrm>
+          <a:prstGeom prst="rect">
+            <a:avLst/>
+          </a:prstGeom>
+          <a:noFill/>
+          <a:ln>
+            <a:noFill/>
+          </a:ln>
+        </p:spPr>
+        <p:txBody>
+          <a:bodyPr wrap="square" lIns="0" tIns="0" rIns="0" bIns="0"/>
+          <a:lstStyle/>
+          <a:p>
+            <a:r>
+              <a:rPr lang="fr-FR" sz="1250">
+                <a:solidFill>
+                  <a:srgbClr val="64748B"/>
+                </a:solidFill>
+              </a:rPr>
+              <a:t>Capture web : page Grafana accessible</a:t>
+            </a:r>
+            <a:endParaRPr lang="fr-FR" sz="1250"/>
+          </a:p>
+        </p:txBody>
+      </p:sp>
+    </p:spTree>
+  </p:cSld>
+  <p:clrMapOvr>
+    <a:masterClrMapping/>
+  </p:clrMapOvr>
+</p:sld>
+</file>
+
+<file path=ppt/slides/slide13.xml><?xml version="1.0" encoding="utf-8"?>
+<p:sld xmlns:a="http://schemas.openxmlformats.org/drawingml/2006/main" xmlns:r="http://schemas.openxmlformats.org/officeDocument/2006/relationships" xmlns:p="http://schemas.openxmlformats.org/presentationml/2006/main">
+  <p:cSld>
+    <p:bg>
+      <p:bgPr>
+        <a:solidFill>
+          <a:srgbClr val="F8FAFC"/>
+        </a:solidFill>
+      </p:bgPr>
+    </p:bg>
+    <p:spTree>
+      <p:nvGrpSpPr>
+        <p:cNvPr id="1" name=""/>
+        <p:cNvGrpSpPr/>
+        <p:nvPr/>
+      </p:nvGrpSpPr>
+      <p:grpSpPr>
+        <a:xfrm>
+          <a:off x="0" y="0"/>
+          <a:ext cx="0" cy="0"/>
+          <a:chOff x="0" y="0"/>
+          <a:chExt cx="0" cy="0"/>
+        </a:xfrm>
+      </p:grpSpPr>
+      <p:sp>
+        <p:nvSpPr>
+          <p:cNvPr id="14" name="Accent bar"/>
+          <p:cNvSpPr/>
+          <p:nvPr/>
+        </p:nvSpPr>
+        <p:spPr>
+          <a:xfrm>
+            <a:off x="0" y="0"/>
+            <a:ext cx="12192000" cy="160000"/>
+          </a:xfrm>
+          <a:prstGeom prst="roundRect">
+            <a:avLst/>
+          </a:prstGeom>
+          <a:solidFill>
+            <a:srgbClr val="0F766E"/>
+          </a:solidFill>
+          <a:ln w="14000">
+            <a:solidFill>
+              <a:srgbClr val="0F766E"/>
+            </a:solidFill>
+          </a:ln>
+        </p:spPr>
+        <p:txBody>
+          <a:bodyPr anchor="ctr" wrap="square" lIns="130000" rIns="130000" tIns="50000" bIns="50000"/>
+          <a:lstStyle/>
+        </p:txBody>
+      </p:sp>
+      <p:sp>
+        <p:nvSpPr>
+          <p:cNvPr id="11" name="Title"/>
+          <p:cNvSpPr txBox="1"/>
+          <p:nvPr/>
+        </p:nvSpPr>
+        <p:spPr>
+          <a:xfrm>
+            <a:off x="600000" y="320000"/>
+            <a:ext cx="10800000" cy="620000"/>
+          </a:xfrm>
+          <a:prstGeom prst="rect">
+            <a:avLst/>
+          </a:prstGeom>
+          <a:noFill/>
+          <a:ln>
+            <a:noFill/>
+          </a:ln>
+        </p:spPr>
+        <p:txBody>
+          <a:bodyPr wrap="square" lIns="0" tIns="0" rIns="0" bIns="0"/>
+          <a:lstStyle/>
+          <a:p>
+            <a:r>
+              <a:rPr lang="fr-FR" sz="3600" b="1">
+                <a:solidFill>
+                  <a:srgbClr val="0F172A"/>
+                </a:solidFill>
+              </a:rPr>
+              <a:t>Preuve API</a:t>
+            </a:r>
+            <a:endParaRPr lang="fr-FR" sz="3600"/>
+          </a:p>
+        </p:txBody>
+      </p:sp>
+      <p:sp>
+        <p:nvSpPr>
+          <p:cNvPr id="12" name="Subtitle"/>
+          <p:cNvSpPr txBox="1"/>
+          <p:nvPr/>
+        </p:nvSpPr>
+        <p:spPr>
+          <a:xfrm>
+            <a:off x="620000" y="930000"/>
+            <a:ext cx="10300000" cy="360000"/>
+          </a:xfrm>
+          <a:prstGeom prst="rect">
+            <a:avLst/>
+          </a:prstGeom>
+          <a:noFill/>
+          <a:ln>
+            <a:noFill/>
+          </a:ln>
+        </p:spPr>
+        <p:txBody>
+          <a:bodyPr wrap="square" lIns="0" tIns="0" rIns="0" bIns="0"/>
+          <a:lstStyle/>
+          <a:p>
+            <a:r>
+              <a:rPr lang="fr-FR" sz="1700">
+                <a:solidFill>
+                  <a:srgbClr val="475569"/>
+                </a:solidFill>
+              </a:rPr>
+              <a:t>Gateway, donnees energie et Grafana health OK</a:t>
+            </a:r>
+            <a:endParaRPr lang="fr-FR" sz="1700"/>
+          </a:p>
+        </p:txBody>
+      </p:sp>
+      <p:pic>
+        <p:nvPicPr>
+          <p:cNvPr id="13" name="Proof image"/>
+          <p:cNvPicPr/>
+          <p:nvPr/>
+        </p:nvPicPr>
+        <p:blipFill>
+          <a:blip r:embed="rId2"/>
+          <a:stretch>
+            <a:fillRect/>
+          </a:stretch>
+        </p:blipFill>
+        <p:spPr>
+          <a:xfrm>
+            <a:off x="1650000" y="1400000"/>
+            <a:ext cx="8890000" cy="5000000"/>
+          </a:xfrm>
+          <a:prstGeom prst="rect">
+            <a:avLst/>
+          </a:prstGeom>
+          <a:ln w="18000">
+            <a:solidFill>
+              <a:srgbClr val="CBD5E1"/>
+            </a:solidFill>
+          </a:ln>
+        </p:spPr>
+      </p:pic>
+      <p:sp>
+        <p:nvSpPr>
+          <p:cNvPr id="15" name="Footer"/>
+          <p:cNvSpPr txBox="1"/>
+          <p:nvPr/>
+        </p:nvSpPr>
+        <p:spPr>
+          <a:xfrm>
+            <a:off x="780000" y="6500000"/>
+            <a:ext cx="8800000" cy="250000"/>
+          </a:xfrm>
+          <a:prstGeom prst="rect">
+            <a:avLst/>
+          </a:prstGeom>
+          <a:noFill/>
+          <a:ln>
+            <a:noFill/>
+          </a:ln>
+        </p:spPr>
+        <p:txBody>
+          <a:bodyPr wrap="square" lIns="0" tIns="0" rIns="0" bIns="0"/>
+          <a:lstStyle/>
+          <a:p>
+            <a:r>
+              <a:rPr lang="fr-FR" sz="1250">
+                <a:solidFill>
+                  <a:srgbClr val="64748B"/>
+                </a:solidFill>
+              </a:rPr>
+              <a:t>Capture de commandes Invoke-RestMethod</a:t>
+            </a:r>
+            <a:endParaRPr lang="fr-FR" sz="1250"/>
+          </a:p>
+        </p:txBody>
+      </p:sp>
+    </p:spTree>
+  </p:cSld>
+  <p:clrMapOvr>
+    <a:masterClrMapping/>
+  </p:clrMapOvr>
+</p:sld>
+</file>
+
+<file path=ppt/slides/slide14.xml><?xml version="1.0" encoding="utf-8"?>
+<p:sld xmlns:a="http://schemas.openxmlformats.org/drawingml/2006/main" xmlns:r="http://schemas.openxmlformats.org/officeDocument/2006/relationships" xmlns:p="http://schemas.openxmlformats.org/presentationml/2006/main">
+  <p:cSld>
+    <p:bg>
+      <p:bgPr>
+        <a:solidFill>
+          <a:srgbClr val="F8FAFC"/>
+        </a:solidFill>
+      </p:bgPr>
+    </p:bg>
+    <p:spTree>
+      <p:nvGrpSpPr>
+        <p:cNvPr id="1" name=""/>
+        <p:cNvGrpSpPr/>
+        <p:nvPr/>
+      </p:nvGrpSpPr>
+      <p:grpSpPr>
+        <a:xfrm>
+          <a:off x="0" y="0"/>
+          <a:ext cx="0" cy="0"/>
+          <a:chOff x="0" y="0"/>
+          <a:chExt cx="0" cy="0"/>
+        </a:xfrm>
+      </p:grpSpPr>
+      <p:sp>
+        <p:nvSpPr>
+          <p:cNvPr id="14" name="Accent bar"/>
+          <p:cNvSpPr/>
+          <p:nvPr/>
+        </p:nvSpPr>
+        <p:spPr>
+          <a:xfrm>
+            <a:off x="0" y="0"/>
+            <a:ext cx="12192000" cy="160000"/>
+          </a:xfrm>
+          <a:prstGeom prst="roundRect">
+            <a:avLst/>
+          </a:prstGeom>
+          <a:solidFill>
+            <a:srgbClr val="0EA5E9"/>
+          </a:solidFill>
+          <a:ln w="14000">
+            <a:solidFill>
+              <a:srgbClr val="0EA5E9"/>
+            </a:solidFill>
+          </a:ln>
+        </p:spPr>
+        <p:txBody>
+          <a:bodyPr anchor="ctr" wrap="square" lIns="130000" rIns="130000" tIns="50000" bIns="50000"/>
+          <a:lstStyle/>
+        </p:txBody>
+      </p:sp>
+      <p:sp>
+        <p:nvSpPr>
+          <p:cNvPr id="11" name="Title"/>
+          <p:cNvSpPr txBox="1"/>
+          <p:nvPr/>
+        </p:nvSpPr>
+        <p:spPr>
+          <a:xfrm>
+            <a:off x="600000" y="320000"/>
+            <a:ext cx="10800000" cy="620000"/>
+          </a:xfrm>
+          <a:prstGeom prst="rect">
+            <a:avLst/>
+          </a:prstGeom>
+          <a:noFill/>
+          <a:ln>
+            <a:noFill/>
+          </a:ln>
+        </p:spPr>
+        <p:txBody>
+          <a:bodyPr wrap="square" lIns="0" tIns="0" rIns="0" bIns="0"/>
+          <a:lstStyle/>
+          <a:p>
+            <a:r>
+              <a:rPr lang="fr-FR" sz="3600" b="1">
+                <a:solidFill>
+                  <a:srgbClr val="0F172A"/>
+                </a:solidFill>
+              </a:rPr>
+              <a:t>Preuve CI/CD</a:t>
+            </a:r>
+            <a:endParaRPr lang="fr-FR" sz="3600"/>
+          </a:p>
+        </p:txBody>
+      </p:sp>
+      <p:sp>
+        <p:nvSpPr>
+          <p:cNvPr id="12" name="Subtitle"/>
+          <p:cNvSpPr txBox="1"/>
+          <p:nvPr/>
+        </p:nvSpPr>
+        <p:spPr>
+          <a:xfrm>
+            <a:off x="620000" y="930000"/>
+            <a:ext cx="10300000" cy="360000"/>
+          </a:xfrm>
+          <a:prstGeom prst="rect">
+            <a:avLst/>
+          </a:prstGeom>
+          <a:noFill/>
+          <a:ln>
+            <a:noFill/>
+          </a:ln>
+        </p:spPr>
+        <p:txBody>
+          <a:bodyPr wrap="square" lIns="0" tIns="0" rIns="0" bIns="0"/>
+          <a:lstStyle/>
+          <a:p>
+            <a:r>
+              <a:rPr lang="fr-FR" sz="1700">
+                <a:solidFill>
+                  <a:srgbClr val="475569"/>
+                </a:solidFill>
+              </a:rPr>
+              <a:t>GitHub Actions au vert</a:t>
+            </a:r>
+            <a:endParaRPr lang="fr-FR" sz="1700"/>
+          </a:p>
+        </p:txBody>
+      </p:sp>
+      <p:pic>
+        <p:nvPicPr>
+          <p:cNvPr id="13" name="Proof image"/>
+          <p:cNvPicPr/>
+          <p:nvPr/>
+        </p:nvPicPr>
+        <p:blipFill>
+          <a:blip r:embed="rId2"/>
+          <a:stretch>
+            <a:fillRect/>
+          </a:stretch>
+        </p:blipFill>
+        <p:spPr>
+          <a:xfrm>
+            <a:off x="1650000" y="1400000"/>
+            <a:ext cx="8890000" cy="5000000"/>
+          </a:xfrm>
+          <a:prstGeom prst="rect">
+            <a:avLst/>
+          </a:prstGeom>
+          <a:ln w="18000">
+            <a:solidFill>
+              <a:srgbClr val="CBD5E1"/>
+            </a:solidFill>
+          </a:ln>
+        </p:spPr>
+      </p:pic>
+      <p:sp>
+        <p:nvSpPr>
+          <p:cNvPr id="15" name="Footer"/>
+          <p:cNvSpPr txBox="1"/>
+          <p:nvPr/>
+        </p:nvSpPr>
+        <p:spPr>
+          <a:xfrm>
+            <a:off x="780000" y="6500000"/>
+            <a:ext cx="8800000" cy="250000"/>
+          </a:xfrm>
+          <a:prstGeom prst="rect">
+            <a:avLst/>
+          </a:prstGeom>
+          <a:noFill/>
+          <a:ln>
+            <a:noFill/>
+          </a:ln>
+        </p:spPr>
+        <p:txBody>
+          <a:bodyPr wrap="square" lIns="0" tIns="0" rIns="0" bIns="0"/>
+          <a:lstStyle/>
+          <a:p>
+            <a:r>
+              <a:rPr lang="fr-FR" sz="1250">
+                <a:solidFill>
+                  <a:srgbClr val="64748B"/>
+                </a:solidFill>
+              </a:rPr>
+              <a:t>Capture de commande : gh run list</a:t>
+            </a:r>
+            <a:endParaRPr lang="fr-FR" sz="1250"/>
+          </a:p>
+        </p:txBody>
+      </p:sp>
+    </p:spTree>
+  </p:cSld>
+  <p:clrMapOvr>
+    <a:masterClrMapping/>
+  </p:clrMapOvr>
+</p:sld>
+</file>
+
+<file path=ppt/slides/slide15.xml><?xml version="1.0" encoding="utf-8"?>
+<p:sld xmlns:a="http://schemas.openxmlformats.org/drawingml/2006/main" xmlns:r="http://schemas.openxmlformats.org/officeDocument/2006/relationships" xmlns:p="http://schemas.openxmlformats.org/presentationml/2006/main">
+  <p:cSld>
+    <p:bg>
+      <p:bgPr>
+        <a:solidFill>
+          <a:srgbClr val="F8FAFC"/>
+        </a:solidFill>
+      </p:bgPr>
+    </p:bg>
+    <p:spTree>
+      <p:nvGrpSpPr>
+        <p:cNvPr id="1" name=""/>
+        <p:cNvGrpSpPr/>
+        <p:nvPr/>
+      </p:nvGrpSpPr>
+      <p:grpSpPr>
+        <a:xfrm>
+          <a:off x="0" y="0"/>
+          <a:ext cx="0" cy="0"/>
+          <a:chOff x="0" y="0"/>
+          <a:chExt cx="0" cy="0"/>
+        </a:xfrm>
+      </p:grpSpPr>
+      <p:sp>
+        <p:nvSpPr>
+          <p:cNvPr id="14" name="Accent bar"/>
+          <p:cNvSpPr/>
+          <p:nvPr/>
+        </p:nvSpPr>
+        <p:spPr>
+          <a:xfrm>
+            <a:off x="0" y="0"/>
+            <a:ext cx="12192000" cy="160000"/>
+          </a:xfrm>
+          <a:prstGeom prst="roundRect">
+            <a:avLst/>
+          </a:prstGeom>
+          <a:solidFill>
+            <a:srgbClr val="DC2626"/>
+          </a:solidFill>
+          <a:ln w="14000">
+            <a:solidFill>
+              <a:srgbClr val="DC2626"/>
+            </a:solidFill>
+          </a:ln>
+        </p:spPr>
+        <p:txBody>
+          <a:bodyPr anchor="ctr" wrap="square" lIns="130000" rIns="130000" tIns="50000" bIns="50000"/>
+          <a:lstStyle/>
+        </p:txBody>
+      </p:sp>
+      <p:sp>
+        <p:nvSpPr>
+          <p:cNvPr id="11" name="Title"/>
+          <p:cNvSpPr txBox="1"/>
+          <p:nvPr/>
+        </p:nvSpPr>
+        <p:spPr>
+          <a:xfrm>
+            <a:off x="600000" y="320000"/>
+            <a:ext cx="10800000" cy="620000"/>
+          </a:xfrm>
+          <a:prstGeom prst="rect">
+            <a:avLst/>
+          </a:prstGeom>
+          <a:noFill/>
+          <a:ln>
+            <a:noFill/>
+          </a:ln>
+        </p:spPr>
+        <p:txBody>
+          <a:bodyPr wrap="square" lIns="0" tIns="0" rIns="0" bIns="0"/>
+          <a:lstStyle/>
+          <a:p>
+            <a:r>
+              <a:rPr lang="fr-FR" sz="3600" b="1">
+                <a:solidFill>
+                  <a:srgbClr val="0F172A"/>
+                </a:solidFill>
+              </a:rPr>
+              <a:t>Tests de demonstration</a:t>
+            </a:r>
+            <a:endParaRPr lang="fr-FR" sz="3600"/>
+          </a:p>
+        </p:txBody>
+      </p:sp>
+      <p:sp>
+        <p:nvSpPr>
+          <p:cNvPr id="12" name="Subtitle"/>
+          <p:cNvSpPr txBox="1"/>
+          <p:nvPr/>
+        </p:nvSpPr>
+        <p:spPr>
+          <a:xfrm>
+            <a:off x="620000" y="930000"/>
+            <a:ext cx="10300000" cy="360000"/>
+          </a:xfrm>
+          <a:prstGeom prst="rect">
+            <a:avLst/>
+          </a:prstGeom>
+          <a:noFill/>
+          <a:ln>
+            <a:noFill/>
+          </a:ln>
+        </p:spPr>
+        <p:txBody>
+          <a:bodyPr wrap="square" lIns="0" tIns="0" rIns="0" bIns="0"/>
+          <a:lstStyle/>
+          <a:p>
+            <a:r>
+              <a:rPr lang="fr-FR" sz="1700">
+                <a:solidFill>
+                  <a:srgbClr val="475569"/>
+                </a:solidFill>
+              </a:rPr>
+              <a:t>Commandes simples a montrer</a:t>
+            </a:r>
+            <a:endParaRPr lang="fr-FR" sz="1700"/>
+          </a:p>
+        </p:txBody>
+      </p:sp>
+      <p:sp>
+        <p:nvSpPr>
+          <p:cNvPr id="13" name="Bullets"/>
+          <p:cNvSpPr txBox="1"/>
+          <p:nvPr/>
+        </p:nvSpPr>
+        <p:spPr>
+          <a:xfrm>
+            <a:off x="780000" y="1580000"/>
+            <a:ext cx="10350000" cy="3200000"/>
+          </a:xfrm>
+          <a:prstGeom prst="rect">
+            <a:avLst/>
+          </a:prstGeom>
+          <a:noFill/>
+          <a:ln>
+            <a:noFill/>
+          </a:ln>
+        </p:spPr>
+        <p:txBody>
+          <a:bodyPr wrap="square" lIns="0" tIns="0" rIns="0" bIns="0"/>
+          <a:lstStyle/>
+          <a:p>
+            <a:r>
+              <a:rPr lang="fr-FR" sz="2250">
+                <a:solidFill>
+                  <a:srgbClr val="1F2937"/>
+                </a:solidFill>
+              </a:rPr>
+              <a:t>- docker compose ps pour voir les conteneurs</a:t>
+            </a:r>
+            <a:endParaRPr lang="fr-FR" sz="2250"/>
+          </a:p>
+          <a:p>
+            <a:r>
+              <a:rPr lang="fr-FR" sz="2250">
+                <a:solidFill>
+                  <a:srgbClr val="1F2937"/>
+                </a:solidFill>
+              </a:rPr>
+              <a:t>- kubectl get pods -n greenops pour voir les pods</a:t>
+            </a:r>
+            <a:endParaRPr lang="fr-FR" sz="2250"/>
+          </a:p>
+          <a:p>
+            <a:r>
+              <a:rPr lang="fr-FR" sz="2250">
+                <a:solidFill>
+                  <a:srgbClr val="1F2937"/>
+                </a:solidFill>
+              </a:rPr>
+              <a:t>- /api/health pour verifier le gateway</a:t>
+            </a:r>
+            <a:endParaRPr lang="fr-FR" sz="2250"/>
+          </a:p>
+          <a:p>
+            <a:r>
+              <a:rPr lang="fr-FR" sz="2250">
+                <a:solidFill>
+                  <a:srgbClr val="1F2937"/>
+                </a:solidFill>
+              </a:rPr>
+              <a:t>- /api/energy/summary pour verifier le service metier</a:t>
+            </a:r>
+            <a:endParaRPr lang="fr-FR" sz="2250"/>
+          </a:p>
+          <a:p>
+            <a:r>
+              <a:rPr lang="fr-FR" sz="2250">
+                <a:solidFill>
+                  <a:srgbClr val="1F2937"/>
+                </a:solidFill>
+              </a:rPr>
+              <a:t>- Suppression d un pod pour montrer la resilience Kubernetes</a:t>
+            </a:r>
+            <a:endParaRPr lang="fr-FR" sz="2250"/>
+          </a:p>
+        </p:txBody>
+      </p:sp>
+      <p:sp>
+        <p:nvSpPr>
+          <p:cNvPr id="15" name="Footer"/>
+          <p:cNvSpPr txBox="1"/>
+          <p:nvPr/>
+        </p:nvSpPr>
+        <p:spPr>
+          <a:xfrm>
+            <a:off x="780000" y="6500000"/>
+            <a:ext cx="8800000" cy="250000"/>
+          </a:xfrm>
+          <a:prstGeom prst="rect">
+            <a:avLst/>
+          </a:prstGeom>
+          <a:noFill/>
+          <a:ln>
+            <a:noFill/>
+          </a:ln>
+        </p:spPr>
+        <p:txBody>
+          <a:bodyPr wrap="square" lIns="0" tIns="0" rIns="0" bIns="0"/>
+          <a:lstStyle/>
+          <a:p>
+            <a:r>
+              <a:rPr lang="fr-FR" sz="1250">
+                <a:solidFill>
+                  <a:srgbClr val="64748B"/>
+                </a:solidFill>
+              </a:rPr>
+              <a:t>Les tests prouvent que la plateforme fonctionne</a:t>
+            </a:r>
+            <a:endParaRPr lang="fr-FR" sz="1250"/>
+          </a:p>
+        </p:txBody>
+      </p:sp>
+    </p:spTree>
+  </p:cSld>
+  <p:clrMapOvr>
+    <a:masterClrMapping/>
+  </p:clrMapOvr>
+</p:sld>
+</file>
+
+<file path=ppt/slides/slide16.xml><?xml version="1.0" encoding="utf-8"?>
+<p:sld xmlns:a="http://schemas.openxmlformats.org/drawingml/2006/main" xmlns:r="http://schemas.openxmlformats.org/officeDocument/2006/relationships" xmlns:p="http://schemas.openxmlformats.org/presentationml/2006/main">
+  <p:cSld>
+    <p:bg>
+      <p:bgPr>
+        <a:solidFill>
+          <a:srgbClr val="F8FAFC"/>
+        </a:solidFill>
+      </p:bgPr>
+    </p:bg>
+    <p:spTree>
+      <p:nvGrpSpPr>
+        <p:cNvPr id="1" name=""/>
+        <p:cNvGrpSpPr/>
+        <p:nvPr/>
+      </p:nvGrpSpPr>
+      <p:grpSpPr>
+        <a:xfrm>
+          <a:off x="0" y="0"/>
+          <a:ext cx="0" cy="0"/>
+          <a:chOff x="0" y="0"/>
+          <a:chExt cx="0" cy="0"/>
+        </a:xfrm>
+      </p:grpSpPr>
+      <p:sp>
+        <p:nvSpPr>
+          <p:cNvPr id="14" name="Accent bar"/>
+          <p:cNvSpPr/>
+          <p:nvPr/>
+        </p:nvSpPr>
+        <p:spPr>
+          <a:xfrm>
+            <a:off x="0" y="0"/>
+            <a:ext cx="12192000" cy="160000"/>
+          </a:xfrm>
+          <a:prstGeom prst="roundRect">
+            <a:avLst/>
+          </a:prstGeom>
+          <a:solidFill>
             <a:srgbClr val="16A34A"/>
           </a:solidFill>
           <a:ln w="14000">
@@ -375,7 +1637,7 @@
         </p:nvSpPr>
         <p:spPr>
           <a:xfrm>
-            <a:off x="600000" y="380000"/>
+            <a:off x="600000" y="320000"/>
             <a:ext cx="10800000" cy="620000"/>
           </a:xfrm>
           <a:prstGeom prst="rect">
@@ -391,14 +1653,14 @@
           <a:lstStyle/>
           <a:p>
             <a:r>
-              <a:rPr lang="fr-FR" sz="3800" b="1">
+              <a:rPr lang="fr-FR" sz="3600" b="1">
                 <a:solidFill>
                   <a:srgbClr val="0F172A"/>
                 </a:solidFill>
               </a:rPr>
               <a:t>Conclusion</a:t>
             </a:r>
-            <a:endParaRPr lang="fr-FR" sz="3800"/>
+            <a:endParaRPr lang="fr-FR" sz="3600"/>
           </a:p>
         </p:txBody>
       </p:sp>
@@ -410,30 +1672,30 @@
         </p:nvSpPr>
         <p:spPr>
           <a:xfrm>
-            <a:off x="620000" y="1010000"/>
-            <a:ext cx="10300000" cy="420000"/>
-          </a:xfrm>
-          <a:prstGeom prst="rect">
-            <a:avLst/>
-          </a:prstGeom>
-          <a:noFill/>
-          <a:ln>
-            <a:noFill/>
-          </a:ln>
-        </p:spPr>
-        <p:txBody>
-          <a:bodyPr wrap="square" lIns="0" tIns="0" rIns="0" bIns="0"/>
-          <a:lstStyle/>
-          <a:p>
-            <a:r>
-              <a:rPr lang="fr-FR" sz="1900">
+            <a:off x="620000" y="930000"/>
+            <a:ext cx="10300000" cy="360000"/>
+          </a:xfrm>
+          <a:prstGeom prst="rect">
+            <a:avLst/>
+          </a:prstGeom>
+          <a:noFill/>
+          <a:ln>
+            <a:noFill/>
+          </a:ln>
+        </p:spPr>
+        <p:txBody>
+          <a:bodyPr wrap="square" lIns="0" tIns="0" rIns="0" bIns="0"/>
+          <a:lstStyle/>
+          <a:p>
+            <a:r>
+              <a:rPr lang="fr-FR" sz="1700">
                 <a:solidFill>
                   <a:srgbClr val="475569"/>
                 </a:solidFill>
               </a:rPr>
               <a:t>Resultat obtenu</a:t>
             </a:r>
-            <a:endParaRPr lang="fr-FR" sz="1900"/>
+            <a:endParaRPr lang="fr-FR" sz="1700"/>
           </a:p>
         </p:txBody>
       </p:sp>
@@ -445,74 +1707,74 @@
         </p:nvSpPr>
         <p:spPr>
           <a:xfrm>
-            <a:off x="780000" y="1720000"/>
-            <a:ext cx="10350000" cy="3300000"/>
-          </a:xfrm>
-          <a:prstGeom prst="rect">
-            <a:avLst/>
-          </a:prstGeom>
-          <a:noFill/>
-          <a:ln>
-            <a:noFill/>
-          </a:ln>
-        </p:spPr>
-        <p:txBody>
-          <a:bodyPr wrap="square" lIns="0" tIns="0" rIns="0" bIns="0"/>
-          <a:lstStyle/>
-          <a:p>
-            <a:r>
-              <a:rPr lang="fr-FR" sz="2300">
+            <a:off x="780000" y="1580000"/>
+            <a:ext cx="10350000" cy="3200000"/>
+          </a:xfrm>
+          <a:prstGeom prst="rect">
+            <a:avLst/>
+          </a:prstGeom>
+          <a:noFill/>
+          <a:ln>
+            <a:noFill/>
+          </a:ln>
+        </p:spPr>
+        <p:txBody>
+          <a:bodyPr wrap="square" lIns="0" tIns="0" rIns="0" bIns="0"/>
+          <a:lstStyle/>
+          <a:p>
+            <a:r>
+              <a:rPr lang="fr-FR" sz="2250">
                 <a:solidFill>
                   <a:srgbClr val="1F2937"/>
                 </a:solidFill>
               </a:rPr>
               <a:t>- Projet Docker et Kubernetes complet</a:t>
             </a:r>
-            <a:endParaRPr lang="fr-FR" sz="2300"/>
-          </a:p>
-          <a:p>
-            <a:r>
-              <a:rPr lang="fr-FR" sz="2300">
+            <a:endParaRPr lang="fr-FR" sz="2250"/>
+          </a:p>
+          <a:p>
+            <a:r>
+              <a:rPr lang="fr-FR" sz="2250">
                 <a:solidFill>
                   <a:srgbClr val="1F2937"/>
                 </a:solidFill>
               </a:rPr>
               <a:t>- Architecture microservices claire</a:t>
             </a:r>
-            <a:endParaRPr lang="fr-FR" sz="2300"/>
-          </a:p>
-          <a:p>
-            <a:r>
-              <a:rPr lang="fr-FR" sz="2300">
+            <a:endParaRPr lang="fr-FR" sz="2250"/>
+          </a:p>
+          <a:p>
+            <a:r>
+              <a:rPr lang="fr-FR" sz="2250">
                 <a:solidFill>
                   <a:srgbClr val="1F2937"/>
                 </a:solidFill>
               </a:rPr>
               <a:t>- Application accessible et supervisable</a:t>
             </a:r>
-            <a:endParaRPr lang="fr-FR" sz="2300"/>
-          </a:p>
-          <a:p>
-            <a:r>
-              <a:rPr lang="fr-FR" sz="2300">
+            <a:endParaRPr lang="fr-FR" sz="2250"/>
+          </a:p>
+          <a:p>
+            <a:r>
+              <a:rPr lang="fr-FR" sz="2250">
                 <a:solidFill>
                   <a:srgbClr val="1F2937"/>
                 </a:solidFill>
               </a:rPr>
               <a:t>- Documentation detaillee et depot GitHub</a:t>
             </a:r>
-            <a:endParaRPr lang="fr-FR" sz="2300"/>
-          </a:p>
-          <a:p>
-            <a:r>
-              <a:rPr lang="fr-FR" sz="2300">
+            <a:endParaRPr lang="fr-FR" sz="2250"/>
+          </a:p>
+          <a:p>
+            <a:r>
+              <a:rPr lang="fr-FR" sz="2250">
                 <a:solidFill>
                   <a:srgbClr val="1F2937"/>
                 </a:solidFill>
               </a:rPr>
               <a:t>- Base solide pour une demonstration ou une soutenance</a:t>
             </a:r>
-            <a:endParaRPr lang="fr-FR" sz="2300"/>
+            <a:endParaRPr lang="fr-FR" sz="2250"/>
           </a:p>
         </p:txBody>
       </p:sp>
@@ -525,7 +1787,7 @@
         <p:spPr>
           <a:xfrm>
             <a:off x="780000" y="6500000"/>
-            <a:ext cx="8200000" cy="250000"/>
+            <a:ext cx="8800000" cy="250000"/>
           </a:xfrm>
           <a:prstGeom prst="rect">
             <a:avLst/>
@@ -619,7 +1881,7 @@
         </p:nvSpPr>
         <p:spPr>
           <a:xfrm>
-            <a:off x="600000" y="380000"/>
+            <a:off x="600000" y="320000"/>
             <a:ext cx="10800000" cy="620000"/>
           </a:xfrm>
           <a:prstGeom prst="rect">
@@ -635,14 +1897,14 @@
           <a:lstStyle/>
           <a:p>
             <a:r>
-              <a:rPr lang="fr-FR" sz="3800" b="1">
+              <a:rPr lang="fr-FR" sz="3600" b="1">
                 <a:solidFill>
                   <a:srgbClr val="0F172A"/>
                 </a:solidFill>
               </a:rPr>
               <a:t>Objectif du projet</a:t>
             </a:r>
-            <a:endParaRPr lang="fr-FR" sz="3800"/>
+            <a:endParaRPr lang="fr-FR" sz="3600"/>
           </a:p>
         </p:txBody>
       </p:sp>
@@ -654,30 +1916,30 @@
         </p:nvSpPr>
         <p:spPr>
           <a:xfrm>
-            <a:off x="620000" y="1010000"/>
-            <a:ext cx="10300000" cy="420000"/>
-          </a:xfrm>
-          <a:prstGeom prst="rect">
-            <a:avLst/>
-          </a:prstGeom>
-          <a:noFill/>
-          <a:ln>
-            <a:noFill/>
-          </a:ln>
-        </p:spPr>
-        <p:txBody>
-          <a:bodyPr wrap="square" lIns="0" tIns="0" rIns="0" bIns="0"/>
-          <a:lstStyle/>
-          <a:p>
-            <a:r>
-              <a:rPr lang="fr-FR" sz="1900">
+            <a:off x="620000" y="930000"/>
+            <a:ext cx="10300000" cy="360000"/>
+          </a:xfrm>
+          <a:prstGeom prst="rect">
+            <a:avLst/>
+          </a:prstGeom>
+          <a:noFill/>
+          <a:ln>
+            <a:noFill/>
+          </a:ln>
+        </p:spPr>
+        <p:txBody>
+          <a:bodyPr wrap="square" lIns="0" tIns="0" rIns="0" bIns="0"/>
+          <a:lstStyle/>
+          <a:p>
+            <a:r>
+              <a:rPr lang="fr-FR" sz="1700">
                 <a:solidFill>
                   <a:srgbClr val="475569"/>
                 </a:solidFill>
               </a:rPr>
               <a:t>Repondre au cahier des charges Docker et Kubernetes</a:t>
             </a:r>
-            <a:endParaRPr lang="fr-FR" sz="1900"/>
+            <a:endParaRPr lang="fr-FR" sz="1700"/>
           </a:p>
         </p:txBody>
       </p:sp>
@@ -689,74 +1951,74 @@
         </p:nvSpPr>
         <p:spPr>
           <a:xfrm>
-            <a:off x="780000" y="1720000"/>
-            <a:ext cx="10350000" cy="3300000"/>
-          </a:xfrm>
-          <a:prstGeom prst="rect">
-            <a:avLst/>
-          </a:prstGeom>
-          <a:noFill/>
-          <a:ln>
-            <a:noFill/>
-          </a:ln>
-        </p:spPr>
-        <p:txBody>
-          <a:bodyPr wrap="square" lIns="0" tIns="0" rIns="0" bIns="0"/>
-          <a:lstStyle/>
-          <a:p>
-            <a:r>
-              <a:rPr lang="fr-FR" sz="2300">
+            <a:off x="780000" y="1580000"/>
+            <a:ext cx="10350000" cy="3200000"/>
+          </a:xfrm>
+          <a:prstGeom prst="rect">
+            <a:avLst/>
+          </a:prstGeom>
+          <a:noFill/>
+          <a:ln>
+            <a:noFill/>
+          </a:ln>
+        </p:spPr>
+        <p:txBody>
+          <a:bodyPr wrap="square" lIns="0" tIns="0" rIns="0" bIns="0"/>
+          <a:lstStyle/>
+          <a:p>
+            <a:r>
+              <a:rPr lang="fr-FR" sz="2250">
                 <a:solidFill>
                   <a:srgbClr val="1F2937"/>
                 </a:solidFill>
               </a:rPr>
               <a:t>- Construire une application complete et demonstrable</a:t>
             </a:r>
-            <a:endParaRPr lang="fr-FR" sz="2300"/>
-          </a:p>
-          <a:p>
-            <a:r>
-              <a:rPr lang="fr-FR" sz="2300">
+            <a:endParaRPr lang="fr-FR" sz="2250"/>
+          </a:p>
+          <a:p>
+            <a:r>
+              <a:rPr lang="fr-FR" sz="2250">
                 <a:solidFill>
                   <a:srgbClr val="1F2937"/>
                 </a:solidFill>
               </a:rPr>
               <a:t>- Montrer la conteneurisation des services</a:t>
             </a:r>
-            <a:endParaRPr lang="fr-FR" sz="2300"/>
-          </a:p>
-          <a:p>
-            <a:r>
-              <a:rPr lang="fr-FR" sz="2300">
+            <a:endParaRPr lang="fr-FR" sz="2250"/>
+          </a:p>
+          <a:p>
+            <a:r>
+              <a:rPr lang="fr-FR" sz="2250">
                 <a:solidFill>
                   <a:srgbClr val="1F2937"/>
                 </a:solidFill>
               </a:rPr>
               <a:t>- Prouver la communication entre conteneurs</a:t>
             </a:r>
-            <a:endParaRPr lang="fr-FR" sz="2300"/>
-          </a:p>
-          <a:p>
-            <a:r>
-              <a:rPr lang="fr-FR" sz="2300">
+            <a:endParaRPr lang="fr-FR" sz="2250"/>
+          </a:p>
+          <a:p>
+            <a:r>
+              <a:rPr lang="fr-FR" sz="2250">
                 <a:solidFill>
                   <a:srgbClr val="1F2937"/>
                 </a:solidFill>
               </a:rPr>
               <a:t>- Migrer vers une orchestration Kubernetes</a:t>
             </a:r>
-            <a:endParaRPr lang="fr-FR" sz="2300"/>
-          </a:p>
-          <a:p>
-            <a:r>
-              <a:rPr lang="fr-FR" sz="2300">
+            <a:endParaRPr lang="fr-FR" sz="2250"/>
+          </a:p>
+          <a:p>
+            <a:r>
+              <a:rPr lang="fr-FR" sz="2250">
                 <a:solidFill>
                   <a:srgbClr val="1F2937"/>
                 </a:solidFill>
               </a:rPr>
               <a:t>- Documenter et versionner le projet sur GitHub</a:t>
             </a:r>
-            <a:endParaRPr lang="fr-FR" sz="2300"/>
+            <a:endParaRPr lang="fr-FR" sz="2250"/>
           </a:p>
         </p:txBody>
       </p:sp>
@@ -769,7 +2031,7 @@
         <p:spPr>
           <a:xfrm>
             <a:off x="780000" y="6500000"/>
-            <a:ext cx="8200000" cy="250000"/>
+            <a:ext cx="8800000" cy="250000"/>
           </a:xfrm>
           <a:prstGeom prst="rect">
             <a:avLst/>
@@ -863,7 +2125,7 @@
         </p:nvSpPr>
         <p:spPr>
           <a:xfrm>
-            <a:off x="600000" y="380000"/>
+            <a:off x="600000" y="320000"/>
             <a:ext cx="10800000" cy="620000"/>
           </a:xfrm>
           <a:prstGeom prst="rect">
@@ -879,14 +2141,14 @@
           <a:lstStyle/>
           <a:p>
             <a:r>
-              <a:rPr lang="fr-FR" sz="3800" b="1">
+              <a:rPr lang="fr-FR" sz="3600" b="1">
                 <a:solidFill>
                   <a:srgbClr val="0F172A"/>
                 </a:solidFill>
               </a:rPr>
               <a:t>Architecture generale</a:t>
             </a:r>
-            <a:endParaRPr lang="fr-FR" sz="3800"/>
+            <a:endParaRPr lang="fr-FR" sz="3600"/>
           </a:p>
         </p:txBody>
       </p:sp>
@@ -898,30 +2160,30 @@
         </p:nvSpPr>
         <p:spPr>
           <a:xfrm>
-            <a:off x="620000" y="1010000"/>
-            <a:ext cx="10300000" cy="420000"/>
-          </a:xfrm>
-          <a:prstGeom prst="rect">
-            <a:avLst/>
-          </a:prstGeom>
-          <a:noFill/>
-          <a:ln>
-            <a:noFill/>
-          </a:ln>
-        </p:spPr>
-        <p:txBody>
-          <a:bodyPr wrap="square" lIns="0" tIns="0" rIns="0" bIns="0"/>
-          <a:lstStyle/>
-          <a:p>
-            <a:r>
-              <a:rPr lang="fr-FR" sz="1900">
+            <a:off x="620000" y="930000"/>
+            <a:ext cx="10300000" cy="360000"/>
+          </a:xfrm>
+          <a:prstGeom prst="rect">
+            <a:avLst/>
+          </a:prstGeom>
+          <a:noFill/>
+          <a:ln>
+            <a:noFill/>
+          </a:ln>
+        </p:spPr>
+        <p:txBody>
+          <a:bodyPr wrap="square" lIns="0" tIns="0" rIns="0" bIns="0"/>
+          <a:lstStyle/>
+          <a:p>
+            <a:r>
+              <a:rPr lang="fr-FR" sz="1700">
                 <a:solidFill>
                   <a:srgbClr val="475569"/>
                 </a:solidFill>
               </a:rPr>
               <a:t>Une application organisee en microservices</a:t>
             </a:r>
-            <a:endParaRPr lang="fr-FR" sz="1900"/>
+            <a:endParaRPr lang="fr-FR" sz="1700"/>
           </a:p>
         </p:txBody>
       </p:sp>
@@ -1139,15 +2401,14 @@
           <a:lstStyle/>
           <a:p>
             <a:r>
-              <a:rPr lang="fr-FR" sz="1550" b="1">
+              <a:rPr lang="fr-FR" sz="1450" b="1">
                 <a:solidFill>
                   <a:srgbClr val="78350F"/>
                 </a:solidFill>
               </a:rPr>
-              <a:t>Services Go
-Auth / Energy / Alerts</a:t>
-            </a:r>
-            <a:endParaRPr lang="fr-FR" sz="1550"/>
+              <a:t>Services Go: Auth / Energy / Alerts</a:t>
+            </a:r>
+            <a:endParaRPr lang="fr-FR" sz="1450"/>
           </a:p>
         </p:txBody>
       </p:sp>
@@ -1261,7 +2522,7 @@
         <p:spPr>
           <a:xfrm>
             <a:off x="780000" y="6500000"/>
-            <a:ext cx="8200000" cy="250000"/>
+            <a:ext cx="8800000" cy="250000"/>
           </a:xfrm>
           <a:prstGeom prst="rect">
             <a:avLst/>
@@ -1355,7 +2616,7 @@
         </p:nvSpPr>
         <p:spPr>
           <a:xfrm>
-            <a:off x="600000" y="380000"/>
+            <a:off x="600000" y="320000"/>
             <a:ext cx="10800000" cy="620000"/>
           </a:xfrm>
           <a:prstGeom prst="rect">
@@ -1371,14 +2632,14 @@
           <a:lstStyle/>
           <a:p>
             <a:r>
-              <a:rPr lang="fr-FR" sz="3800" b="1">
+              <a:rPr lang="fr-FR" sz="3600" b="1">
                 <a:solidFill>
                   <a:srgbClr val="0F172A"/>
                 </a:solidFill>
               </a:rPr>
               <a:t>Stack technique</a:t>
             </a:r>
-            <a:endParaRPr lang="fr-FR" sz="3800"/>
+            <a:endParaRPr lang="fr-FR" sz="3600"/>
           </a:p>
         </p:txBody>
       </p:sp>
@@ -1390,30 +2651,30 @@
         </p:nvSpPr>
         <p:spPr>
           <a:xfrm>
-            <a:off x="620000" y="1010000"/>
-            <a:ext cx="10300000" cy="420000"/>
-          </a:xfrm>
-          <a:prstGeom prst="rect">
-            <a:avLst/>
-          </a:prstGeom>
-          <a:noFill/>
-          <a:ln>
-            <a:noFill/>
-          </a:ln>
-        </p:spPr>
-        <p:txBody>
-          <a:bodyPr wrap="square" lIns="0" tIns="0" rIns="0" bIns="0"/>
-          <a:lstStyle/>
-          <a:p>
-            <a:r>
-              <a:rPr lang="fr-FR" sz="1900">
+            <a:off x="620000" y="930000"/>
+            <a:ext cx="10300000" cy="360000"/>
+          </a:xfrm>
+          <a:prstGeom prst="rect">
+            <a:avLst/>
+          </a:prstGeom>
+          <a:noFill/>
+          <a:ln>
+            <a:noFill/>
+          </a:ln>
+        </p:spPr>
+        <p:txBody>
+          <a:bodyPr wrap="square" lIns="0" tIns="0" rIns="0" bIns="0"/>
+          <a:lstStyle/>
+          <a:p>
+            <a:r>
+              <a:rPr lang="fr-FR" sz="1700">
                 <a:solidFill>
                   <a:srgbClr val="475569"/>
                 </a:solidFill>
               </a:rPr>
               <a:t>Technologies utilisees</a:t>
             </a:r>
-            <a:endParaRPr lang="fr-FR" sz="1900"/>
+            <a:endParaRPr lang="fr-FR" sz="1700"/>
           </a:p>
         </p:txBody>
       </p:sp>
@@ -1425,85 +2686,85 @@
         </p:nvSpPr>
         <p:spPr>
           <a:xfrm>
-            <a:off x="780000" y="1720000"/>
-            <a:ext cx="10350000" cy="3300000"/>
-          </a:xfrm>
-          <a:prstGeom prst="rect">
-            <a:avLst/>
-          </a:prstGeom>
-          <a:noFill/>
-          <a:ln>
-            <a:noFill/>
-          </a:ln>
-        </p:spPr>
-        <p:txBody>
-          <a:bodyPr wrap="square" lIns="0" tIns="0" rIns="0" bIns="0"/>
-          <a:lstStyle/>
-          <a:p>
-            <a:r>
-              <a:rPr lang="fr-FR" sz="2300">
+            <a:off x="780000" y="1580000"/>
+            <a:ext cx="10350000" cy="3200000"/>
+          </a:xfrm>
+          <a:prstGeom prst="rect">
+            <a:avLst/>
+          </a:prstGeom>
+          <a:noFill/>
+          <a:ln>
+            <a:noFill/>
+          </a:ln>
+        </p:spPr>
+        <p:txBody>
+          <a:bodyPr wrap="square" lIns="0" tIns="0" rIns="0" bIns="0"/>
+          <a:lstStyle/>
+          <a:p>
+            <a:r>
+              <a:rPr lang="fr-FR" sz="2250">
                 <a:solidFill>
                   <a:srgbClr val="1F2937"/>
                 </a:solidFill>
               </a:rPr>
               <a:t>- Frontend React statique servi par Caddy</a:t>
             </a:r>
-            <a:endParaRPr lang="fr-FR" sz="2300"/>
-          </a:p>
-          <a:p>
-            <a:r>
-              <a:rPr lang="fr-FR" sz="2300">
+            <a:endParaRPr lang="fr-FR" sz="2250"/>
+          </a:p>
+          <a:p>
+            <a:r>
+              <a:rPr lang="fr-FR" sz="2250">
                 <a:solidFill>
                   <a:srgbClr val="1F2937"/>
                 </a:solidFill>
               </a:rPr>
               <a:t>- Backend Go : gateway, auth, energy, alerts</a:t>
             </a:r>
-            <a:endParaRPr lang="fr-FR" sz="2300"/>
-          </a:p>
-          <a:p>
-            <a:r>
-              <a:rPr lang="fr-FR" sz="2300">
+            <a:endParaRPr lang="fr-FR" sz="2250"/>
+          </a:p>
+          <a:p>
+            <a:r>
+              <a:rPr lang="fr-FR" sz="2250">
                 <a:solidFill>
                   <a:srgbClr val="1F2937"/>
                 </a:solidFill>
               </a:rPr>
               <a:t>- PostgreSQL pour la persistance</a:t>
             </a:r>
-            <a:endParaRPr lang="fr-FR" sz="2300"/>
-          </a:p>
-          <a:p>
-            <a:r>
-              <a:rPr lang="fr-FR" sz="2300">
+            <a:endParaRPr lang="fr-FR" sz="2250"/>
+          </a:p>
+          <a:p>
+            <a:r>
+              <a:rPr lang="fr-FR" sz="2250">
                 <a:solidFill>
                   <a:srgbClr val="1F2937"/>
                 </a:solidFill>
               </a:rPr>
               <a:t>- Redis pour le cache</a:t>
             </a:r>
-            <a:endParaRPr lang="fr-FR" sz="2300"/>
-          </a:p>
-          <a:p>
-            <a:r>
-              <a:rPr lang="fr-FR" sz="2300">
+            <a:endParaRPr lang="fr-FR" sz="2250"/>
+          </a:p>
+          <a:p>
+            <a:r>
+              <a:rPr lang="fr-FR" sz="2250">
                 <a:solidFill>
                   <a:srgbClr val="1F2937"/>
                 </a:solidFill>
               </a:rPr>
               <a:t>- Prometheus pour les metriques</a:t>
             </a:r>
-            <a:endParaRPr lang="fr-FR" sz="2300"/>
-          </a:p>
-          <a:p>
-            <a:r>
-              <a:rPr lang="fr-FR" sz="2300">
+            <a:endParaRPr lang="fr-FR" sz="2250"/>
+          </a:p>
+          <a:p>
+            <a:r>
+              <a:rPr lang="fr-FR" sz="2250">
                 <a:solidFill>
                   <a:srgbClr val="1F2937"/>
                 </a:solidFill>
               </a:rPr>
               <a:t>- Grafana pour les tableaux de bord</a:t>
             </a:r>
-            <a:endParaRPr lang="fr-FR" sz="2300"/>
+            <a:endParaRPr lang="fr-FR" sz="2250"/>
           </a:p>
         </p:txBody>
       </p:sp>
@@ -1516,7 +2777,7 @@
         <p:spPr>
           <a:xfrm>
             <a:off x="780000" y="6500000"/>
-            <a:ext cx="8200000" cy="250000"/>
+            <a:ext cx="8800000" cy="250000"/>
           </a:xfrm>
           <a:prstGeom prst="rect">
             <a:avLst/>
@@ -1610,7 +2871,7 @@
         </p:nvSpPr>
         <p:spPr>
           <a:xfrm>
-            <a:off x="600000" y="380000"/>
+            <a:off x="600000" y="320000"/>
             <a:ext cx="10800000" cy="620000"/>
           </a:xfrm>
           <a:prstGeom prst="rect">
@@ -1626,14 +2887,14 @@
           <a:lstStyle/>
           <a:p>
             <a:r>
-              <a:rPr lang="fr-FR" sz="3800" b="1">
+              <a:rPr lang="fr-FR" sz="3600" b="1">
                 <a:solidFill>
                   <a:srgbClr val="0F172A"/>
                 </a:solidFill>
               </a:rPr>
               <a:t>Phase Docker Compose</a:t>
             </a:r>
-            <a:endParaRPr lang="fr-FR" sz="3800"/>
+            <a:endParaRPr lang="fr-FR" sz="3600"/>
           </a:p>
         </p:txBody>
       </p:sp>
@@ -1645,30 +2906,30 @@
         </p:nvSpPr>
         <p:spPr>
           <a:xfrm>
-            <a:off x="620000" y="1010000"/>
-            <a:ext cx="10300000" cy="420000"/>
-          </a:xfrm>
-          <a:prstGeom prst="rect">
-            <a:avLst/>
-          </a:prstGeom>
-          <a:noFill/>
-          <a:ln>
-            <a:noFill/>
-          </a:ln>
-        </p:spPr>
-        <p:txBody>
-          <a:bodyPr wrap="square" lIns="0" tIns="0" rIns="0" bIns="0"/>
-          <a:lstStyle/>
-          <a:p>
-            <a:r>
-              <a:rPr lang="fr-FR" sz="1900">
+            <a:off x="620000" y="930000"/>
+            <a:ext cx="10300000" cy="360000"/>
+          </a:xfrm>
+          <a:prstGeom prst="rect">
+            <a:avLst/>
+          </a:prstGeom>
+          <a:noFill/>
+          <a:ln>
+            <a:noFill/>
+          </a:ln>
+        </p:spPr>
+        <p:txBody>
+          <a:bodyPr wrap="square" lIns="0" tIns="0" rIns="0" bIns="0"/>
+          <a:lstStyle/>
+          <a:p>
+            <a:r>
+              <a:rPr lang="fr-FR" sz="1700">
                 <a:solidFill>
                   <a:srgbClr val="475569"/>
                 </a:solidFill>
               </a:rPr>
               <a:t>Premier deploiement de la plateforme</a:t>
             </a:r>
-            <a:endParaRPr lang="fr-FR" sz="1900"/>
+            <a:endParaRPr lang="fr-FR" sz="1700"/>
           </a:p>
         </p:txBody>
       </p:sp>
@@ -1680,74 +2941,74 @@
         </p:nvSpPr>
         <p:spPr>
           <a:xfrm>
-            <a:off x="780000" y="1720000"/>
-            <a:ext cx="10350000" cy="3300000"/>
-          </a:xfrm>
-          <a:prstGeom prst="rect">
-            <a:avLst/>
-          </a:prstGeom>
-          <a:noFill/>
-          <a:ln>
-            <a:noFill/>
-          </a:ln>
-        </p:spPr>
-        <p:txBody>
-          <a:bodyPr wrap="square" lIns="0" tIns="0" rIns="0" bIns="0"/>
-          <a:lstStyle/>
-          <a:p>
-            <a:r>
-              <a:rPr lang="fr-FR" sz="2300">
+            <a:off x="780000" y="1580000"/>
+            <a:ext cx="10350000" cy="3200000"/>
+          </a:xfrm>
+          <a:prstGeom prst="rect">
+            <a:avLst/>
+          </a:prstGeom>
+          <a:noFill/>
+          <a:ln>
+            <a:noFill/>
+          </a:ln>
+        </p:spPr>
+        <p:txBody>
+          <a:bodyPr wrap="square" lIns="0" tIns="0" rIns="0" bIns="0"/>
+          <a:lstStyle/>
+          <a:p>
+            <a:r>
+              <a:rPr lang="fr-FR" sz="2250">
                 <a:solidFill>
                   <a:srgbClr val="1F2937"/>
                 </a:solidFill>
               </a:rPr>
               <a:t>- Un fichier compose.yaml lance toute la stack</a:t>
             </a:r>
-            <a:endParaRPr lang="fr-FR" sz="2300"/>
-          </a:p>
-          <a:p>
-            <a:r>
-              <a:rPr lang="fr-FR" sz="2300">
+            <a:endParaRPr lang="fr-FR" sz="2250"/>
+          </a:p>
+          <a:p>
+            <a:r>
+              <a:rPr lang="fr-FR" sz="2250">
                 <a:solidFill>
                   <a:srgbClr val="1F2937"/>
                 </a:solidFill>
               </a:rPr>
               <a:t>- Les services communiquent par nom DNS Docker</a:t>
             </a:r>
-            <a:endParaRPr lang="fr-FR" sz="2300"/>
-          </a:p>
-          <a:p>
-            <a:r>
-              <a:rPr lang="fr-FR" sz="2300">
+            <a:endParaRPr lang="fr-FR" sz="2250"/>
+          </a:p>
+          <a:p>
+            <a:r>
+              <a:rPr lang="fr-FR" sz="2250">
                 <a:solidFill>
                   <a:srgbClr val="1F2937"/>
                 </a:solidFill>
               </a:rPr>
               <a:t>- Les volumes conservent les donnees</a:t>
             </a:r>
-            <a:endParaRPr lang="fr-FR" sz="2300"/>
-          </a:p>
-          <a:p>
-            <a:r>
-              <a:rPr lang="fr-FR" sz="2300">
+            <a:endParaRPr lang="fr-FR" sz="2250"/>
+          </a:p>
+          <a:p>
+            <a:r>
+              <a:rPr lang="fr-FR" sz="2250">
                 <a:solidFill>
                   <a:srgbClr val="1F2937"/>
                 </a:solidFill>
               </a:rPr>
               <a:t>- Les ports 8080, 3001 et 9090 exposent les services</a:t>
             </a:r>
-            <a:endParaRPr lang="fr-FR" sz="2300"/>
-          </a:p>
-          <a:p>
-            <a:r>
-              <a:rPr lang="fr-FR" sz="2300">
+            <a:endParaRPr lang="fr-FR" sz="2250"/>
+          </a:p>
+          <a:p>
+            <a:r>
+              <a:rPr lang="fr-FR" sz="2250">
                 <a:solidFill>
                   <a:srgbClr val="1F2937"/>
                 </a:solidFill>
               </a:rPr>
               <a:t>- Les logs Docker permettent le diagnostic</a:t>
             </a:r>
-            <a:endParaRPr lang="fr-FR" sz="2300"/>
+            <a:endParaRPr lang="fr-FR" sz="2250"/>
           </a:p>
         </p:txBody>
       </p:sp>
@@ -1760,7 +3021,7 @@
         <p:spPr>
           <a:xfrm>
             <a:off x="780000" y="6500000"/>
-            <a:ext cx="8200000" cy="250000"/>
+            <a:ext cx="8800000" cy="250000"/>
           </a:xfrm>
           <a:prstGeom prst="rect">
             <a:avLst/>
@@ -1833,11 +3094,11 @@
             <a:avLst/>
           </a:prstGeom>
           <a:solidFill>
-            <a:srgbClr val="7C3AED"/>
+            <a:srgbClr val="2563EB"/>
           </a:solidFill>
           <a:ln w="14000">
             <a:solidFill>
-              <a:srgbClr val="7C3AED"/>
+              <a:srgbClr val="2563EB"/>
             </a:solidFill>
           </a:ln>
         </p:spPr>
@@ -1854,7 +3115,7 @@
         </p:nvSpPr>
         <p:spPr>
           <a:xfrm>
-            <a:off x="600000" y="380000"/>
+            <a:off x="600000" y="320000"/>
             <a:ext cx="10800000" cy="620000"/>
           </a:xfrm>
           <a:prstGeom prst="rect">
@@ -1870,14 +3131,14 @@
           <a:lstStyle/>
           <a:p>
             <a:r>
-              <a:rPr lang="fr-FR" sz="3800" b="1">
+              <a:rPr lang="fr-FR" sz="3600" b="1">
                 <a:solidFill>
                   <a:srgbClr val="0F172A"/>
                 </a:solidFill>
               </a:rPr>
-              <a:t>Phase Kubernetes</a:t>
-            </a:r>
-            <a:endParaRPr lang="fr-FR" sz="3800"/>
+              <a:t>Preuve Docker Compose</a:t>
+            </a:r>
+            <a:endParaRPr lang="fr-FR" sz="3600"/>
           </a:p>
         </p:txBody>
       </p:sp>
@@ -1889,112 +3150,60 @@
         </p:nvSpPr>
         <p:spPr>
           <a:xfrm>
-            <a:off x="620000" y="1010000"/>
-            <a:ext cx="10300000" cy="420000"/>
-          </a:xfrm>
-          <a:prstGeom prst="rect">
-            <a:avLst/>
-          </a:prstGeom>
-          <a:noFill/>
-          <a:ln>
-            <a:noFill/>
-          </a:ln>
-        </p:spPr>
-        <p:txBody>
-          <a:bodyPr wrap="square" lIns="0" tIns="0" rIns="0" bIns="0"/>
-          <a:lstStyle/>
-          <a:p>
-            <a:r>
-              <a:rPr lang="fr-FR" sz="1900">
+            <a:off x="620000" y="930000"/>
+            <a:ext cx="10300000" cy="360000"/>
+          </a:xfrm>
+          <a:prstGeom prst="rect">
+            <a:avLst/>
+          </a:prstGeom>
+          <a:noFill/>
+          <a:ln>
+            <a:noFill/>
+          </a:ln>
+        </p:spPr>
+        <p:txBody>
+          <a:bodyPr wrap="square" lIns="0" tIns="0" rIns="0" bIns="0"/>
+          <a:lstStyle/>
+          <a:p>
+            <a:r>
+              <a:rPr lang="fr-FR" sz="1700">
                 <a:solidFill>
                   <a:srgbClr val="475569"/>
                 </a:solidFill>
               </a:rPr>
-              <a:t>Migration vers une orchestration locale</a:t>
-            </a:r>
-            <a:endParaRPr lang="fr-FR" sz="1900"/>
-          </a:p>
-        </p:txBody>
-      </p:sp>
-      <p:sp>
-        <p:nvSpPr>
-          <p:cNvPr id="13" name="Bullets"/>
-          <p:cNvSpPr txBox="1"/>
-          <p:nvPr/>
-        </p:nvSpPr>
-        <p:spPr>
-          <a:xfrm>
-            <a:off x="780000" y="1720000"/>
-            <a:ext cx="10350000" cy="3300000"/>
-          </a:xfrm>
-          <a:prstGeom prst="rect">
-            <a:avLst/>
-          </a:prstGeom>
-          <a:noFill/>
-          <a:ln>
-            <a:noFill/>
-          </a:ln>
-        </p:spPr>
-        <p:txBody>
-          <a:bodyPr wrap="square" lIns="0" tIns="0" rIns="0" bIns="0"/>
-          <a:lstStyle/>
-          <a:p>
-            <a:r>
-              <a:rPr lang="fr-FR" sz="2300">
-                <a:solidFill>
-                  <a:srgbClr val="1F2937"/>
-                </a:solidFill>
-              </a:rPr>
-              <a:t>- Namespace greenops dedie</a:t>
-            </a:r>
-            <a:endParaRPr lang="fr-FR" sz="2300"/>
-          </a:p>
-          <a:p>
-            <a:r>
-              <a:rPr lang="fr-FR" sz="2300">
-                <a:solidFill>
-                  <a:srgbClr val="1F2937"/>
-                </a:solidFill>
-              </a:rPr>
-              <a:t>- Deployments et Services pour chaque composant</a:t>
-            </a:r>
-            <a:endParaRPr lang="fr-FR" sz="2300"/>
-          </a:p>
-          <a:p>
-            <a:r>
-              <a:rPr lang="fr-FR" sz="2300">
-                <a:solidFill>
-                  <a:srgbClr val="1F2937"/>
-                </a:solidFill>
-              </a:rPr>
-              <a:t>- Secrets et ConfigMaps pour la configuration</a:t>
-            </a:r>
-            <a:endParaRPr lang="fr-FR" sz="2300"/>
-          </a:p>
-          <a:p>
-            <a:r>
-              <a:rPr lang="fr-FR" sz="2300">
-                <a:solidFill>
-                  <a:srgbClr val="1F2937"/>
-                </a:solidFill>
-              </a:rPr>
-              <a:t>- PVC pour PostgreSQL, Prometheus et Grafana</a:t>
-            </a:r>
-            <a:endParaRPr lang="fr-FR" sz="2300"/>
-          </a:p>
-          <a:p>
-            <a:r>
-              <a:rPr lang="fr-FR" sz="2300">
-                <a:solidFill>
-                  <a:srgbClr val="1F2937"/>
-                </a:solidFill>
-              </a:rPr>
-              <a:t>- Probes, HPA et NetworkPolicies pour une approche professionnelle</a:t>
-            </a:r>
-            <a:endParaRPr lang="fr-FR" sz="2300"/>
-          </a:p>
-        </p:txBody>
-      </p:sp>
+              <a:t>Services declares dans compose.yaml</a:t>
+            </a:r>
+            <a:endParaRPr lang="fr-FR" sz="1700"/>
+          </a:p>
+        </p:txBody>
+      </p:sp>
+      <p:pic>
+        <p:nvPicPr>
+          <p:cNvPr id="13" name="Proof image"/>
+          <p:cNvPicPr/>
+          <p:nvPr/>
+        </p:nvPicPr>
+        <p:blipFill>
+          <a:blip r:embed="rId2"/>
+          <a:stretch>
+            <a:fillRect/>
+          </a:stretch>
+        </p:blipFill>
+        <p:spPr>
+          <a:xfrm>
+            <a:off x="1650000" y="1400000"/>
+            <a:ext cx="8890000" cy="5000000"/>
+          </a:xfrm>
+          <a:prstGeom prst="rect">
+            <a:avLst/>
+          </a:prstGeom>
+          <a:ln w="18000">
+            <a:solidFill>
+              <a:srgbClr val="CBD5E1"/>
+            </a:solidFill>
+          </a:ln>
+        </p:spPr>
+      </p:pic>
       <p:sp>
         <p:nvSpPr>
           <p:cNvPr id="15" name="Footer"/>
@@ -2004,7 +3213,7 @@
         <p:spPr>
           <a:xfrm>
             <a:off x="780000" y="6500000"/>
-            <a:ext cx="8200000" cy="250000"/>
+            <a:ext cx="8800000" cy="250000"/>
           </a:xfrm>
           <a:prstGeom prst="rect">
             <a:avLst/>
@@ -2024,7 +3233,7 @@
                   <a:srgbClr val="64748B"/>
                 </a:solidFill>
               </a:rPr>
-              <a:t>Kubernetes montre resilience, scaling et organisation</a:t>
+              <a:t>Capture de commande : docker compose config --services</a:t>
             </a:r>
             <a:endParaRPr lang="fr-FR" sz="1250"/>
           </a:p>
@@ -2077,11 +3286,11 @@
             <a:avLst/>
           </a:prstGeom>
           <a:solidFill>
-            <a:srgbClr val="F59E0B"/>
+            <a:srgbClr val="16A34A"/>
           </a:solidFill>
           <a:ln w="14000">
             <a:solidFill>
-              <a:srgbClr val="F59E0B"/>
+              <a:srgbClr val="16A34A"/>
             </a:solidFill>
           </a:ln>
         </p:spPr>
@@ -2098,7 +3307,7 @@
         </p:nvSpPr>
         <p:spPr>
           <a:xfrm>
-            <a:off x="600000" y="380000"/>
+            <a:off x="600000" y="320000"/>
             <a:ext cx="10800000" cy="620000"/>
           </a:xfrm>
           <a:prstGeom prst="rect">
@@ -2114,14 +3323,14 @@
           <a:lstStyle/>
           <a:p>
             <a:r>
-              <a:rPr lang="fr-FR" sz="3800" b="1">
+              <a:rPr lang="fr-FR" sz="3600" b="1">
                 <a:solidFill>
                   <a:srgbClr val="0F172A"/>
                 </a:solidFill>
               </a:rPr>
-              <a:t>Observabilite</a:t>
-            </a:r>
-            <a:endParaRPr lang="fr-FR" sz="3800"/>
+              <a:t>Application en fonctionnement</a:t>
+            </a:r>
+            <a:endParaRPr lang="fr-FR" sz="3600"/>
           </a:p>
         </p:txBody>
       </p:sp>
@@ -2133,112 +3342,60 @@
         </p:nvSpPr>
         <p:spPr>
           <a:xfrm>
-            <a:off x="620000" y="1010000"/>
-            <a:ext cx="10300000" cy="420000"/>
-          </a:xfrm>
-          <a:prstGeom prst="rect">
-            <a:avLst/>
-          </a:prstGeom>
-          <a:noFill/>
-          <a:ln>
-            <a:noFill/>
-          </a:ln>
-        </p:spPr>
-        <p:txBody>
-          <a:bodyPr wrap="square" lIns="0" tIns="0" rIns="0" bIns="0"/>
-          <a:lstStyle/>
-          <a:p>
-            <a:r>
-              <a:rPr lang="fr-FR" sz="1900">
+            <a:off x="620000" y="930000"/>
+            <a:ext cx="10300000" cy="360000"/>
+          </a:xfrm>
+          <a:prstGeom prst="rect">
+            <a:avLst/>
+          </a:prstGeom>
+          <a:noFill/>
+          <a:ln>
+            <a:noFill/>
+          </a:ln>
+        </p:spPr>
+        <p:txBody>
+          <a:bodyPr wrap="square" lIns="0" tIns="0" rIns="0" bIns="0"/>
+          <a:lstStyle/>
+          <a:p>
+            <a:r>
+              <a:rPr lang="fr-FR" sz="1700">
                 <a:solidFill>
                   <a:srgbClr val="475569"/>
                 </a:solidFill>
               </a:rPr>
-              <a:t>Prometheus + Grafana</a:t>
-            </a:r>
-            <a:endParaRPr lang="fr-FR" sz="1900"/>
-          </a:p>
-        </p:txBody>
-      </p:sp>
-      <p:sp>
-        <p:nvSpPr>
-          <p:cNvPr id="13" name="Bullets"/>
-          <p:cNvSpPr txBox="1"/>
-          <p:nvPr/>
-        </p:nvSpPr>
-        <p:spPr>
-          <a:xfrm>
-            <a:off x="780000" y="1720000"/>
-            <a:ext cx="10350000" cy="3300000"/>
-          </a:xfrm>
-          <a:prstGeom prst="rect">
-            <a:avLst/>
-          </a:prstGeom>
-          <a:noFill/>
-          <a:ln>
-            <a:noFill/>
-          </a:ln>
-        </p:spPr>
-        <p:txBody>
-          <a:bodyPr wrap="square" lIns="0" tIns="0" rIns="0" bIns="0"/>
-          <a:lstStyle/>
-          <a:p>
-            <a:r>
-              <a:rPr lang="fr-FR" sz="2300">
-                <a:solidFill>
-                  <a:srgbClr val="1F2937"/>
-                </a:solidFill>
-              </a:rPr>
-              <a:t>- Les services exposent des endpoints /metrics</a:t>
-            </a:r>
-            <a:endParaRPr lang="fr-FR" sz="2300"/>
-          </a:p>
-          <a:p>
-            <a:r>
-              <a:rPr lang="fr-FR" sz="2300">
-                <a:solidFill>
-                  <a:srgbClr val="1F2937"/>
-                </a:solidFill>
-              </a:rPr>
-              <a:t>- Prometheus collecte les metriques techniques</a:t>
-            </a:r>
-            <a:endParaRPr lang="fr-FR" sz="2300"/>
-          </a:p>
-          <a:p>
-            <a:r>
-              <a:rPr lang="fr-FR" sz="2300">
-                <a:solidFill>
-                  <a:srgbClr val="1F2937"/>
-                </a:solidFill>
-              </a:rPr>
-              <a:t>- Grafana affiche un dashboard GreenOps Overview</a:t>
-            </a:r>
-            <a:endParaRPr lang="fr-FR" sz="2300"/>
-          </a:p>
-          <a:p>
-            <a:r>
-              <a:rPr lang="fr-FR" sz="2300">
-                <a:solidFill>
-                  <a:srgbClr val="1F2937"/>
-                </a:solidFill>
-              </a:rPr>
-              <a:t>- La supervision montre l etat et l activite de la plateforme</a:t>
-            </a:r>
-            <a:endParaRPr lang="fr-FR" sz="2300"/>
-          </a:p>
-          <a:p>
-            <a:r>
-              <a:rPr lang="fr-FR" sz="2300">
-                <a:solidFill>
-                  <a:srgbClr val="1F2937"/>
-                </a:solidFill>
-              </a:rPr>
-              <a:t>- Les logs completent le diagnostic</a:t>
-            </a:r>
-            <a:endParaRPr lang="fr-FR" sz="2300"/>
-          </a:p>
-        </p:txBody>
-      </p:sp>
+              <a:t>Capture live de GreenOps sur la VM</a:t>
+            </a:r>
+            <a:endParaRPr lang="fr-FR" sz="1700"/>
+          </a:p>
+        </p:txBody>
+      </p:sp>
+      <p:pic>
+        <p:nvPicPr>
+          <p:cNvPr id="13" name="Proof image"/>
+          <p:cNvPicPr/>
+          <p:nvPr/>
+        </p:nvPicPr>
+        <p:blipFill>
+          <a:blip r:embed="rId2"/>
+          <a:stretch>
+            <a:fillRect/>
+          </a:stretch>
+        </p:blipFill>
+        <p:spPr>
+          <a:xfrm>
+            <a:off x="1650000" y="1400000"/>
+            <a:ext cx="8890000" cy="5000000"/>
+          </a:xfrm>
+          <a:prstGeom prst="rect">
+            <a:avLst/>
+          </a:prstGeom>
+          <a:ln w="18000">
+            <a:solidFill>
+              <a:srgbClr val="CBD5E1"/>
+            </a:solidFill>
+          </a:ln>
+        </p:spPr>
+      </p:pic>
       <p:sp>
         <p:nvSpPr>
           <p:cNvPr id="15" name="Footer"/>
@@ -2248,7 +3405,7 @@
         <p:spPr>
           <a:xfrm>
             <a:off x="780000" y="6500000"/>
-            <a:ext cx="8200000" cy="250000"/>
+            <a:ext cx="8800000" cy="250000"/>
           </a:xfrm>
           <a:prstGeom prst="rect">
             <a:avLst/>
@@ -2268,7 +3425,7 @@
                   <a:srgbClr val="64748B"/>
                 </a:solidFill>
               </a:rPr>
-              <a:t>La plateforme est observable, pas seulement lancee</a:t>
+              <a:t>URL testee : http://192.168.242.132:8080</a:t>
             </a:r>
             <a:endParaRPr lang="fr-FR" sz="1250"/>
           </a:p>
@@ -2321,11 +3478,11 @@
             <a:avLst/>
           </a:prstGeom>
           <a:solidFill>
-            <a:srgbClr val="0F766E"/>
+            <a:srgbClr val="7C3AED"/>
           </a:solidFill>
           <a:ln w="14000">
             <a:solidFill>
-              <a:srgbClr val="0F766E"/>
+              <a:srgbClr val="7C3AED"/>
             </a:solidFill>
           </a:ln>
         </p:spPr>
@@ -2342,7 +3499,7 @@
         </p:nvSpPr>
         <p:spPr>
           <a:xfrm>
-            <a:off x="600000" y="380000"/>
+            <a:off x="600000" y="320000"/>
             <a:ext cx="10800000" cy="620000"/>
           </a:xfrm>
           <a:prstGeom prst="rect">
@@ -2358,14 +3515,14 @@
           <a:lstStyle/>
           <a:p>
             <a:r>
-              <a:rPr lang="fr-FR" sz="3800" b="1">
+              <a:rPr lang="fr-FR" sz="3600" b="1">
                 <a:solidFill>
                   <a:srgbClr val="0F172A"/>
                 </a:solidFill>
               </a:rPr>
-              <a:t>Acces reseau</a:t>
-            </a:r>
-            <a:endParaRPr lang="fr-FR" sz="3800"/>
+              <a:t>Phase Kubernetes</a:t>
+            </a:r>
+            <a:endParaRPr lang="fr-FR" sz="3600"/>
           </a:p>
         </p:txBody>
       </p:sp>
@@ -2377,30 +3534,30 @@
         </p:nvSpPr>
         <p:spPr>
           <a:xfrm>
-            <a:off x="620000" y="1010000"/>
-            <a:ext cx="10300000" cy="420000"/>
-          </a:xfrm>
-          <a:prstGeom prst="rect">
-            <a:avLst/>
-          </a:prstGeom>
-          <a:noFill/>
-          <a:ln>
-            <a:noFill/>
-          </a:ln>
-        </p:spPr>
-        <p:txBody>
-          <a:bodyPr wrap="square" lIns="0" tIns="0" rIns="0" bIns="0"/>
-          <a:lstStyle/>
-          <a:p>
-            <a:r>
-              <a:rPr lang="fr-FR" sz="1900">
+            <a:off x="620000" y="930000"/>
+            <a:ext cx="10300000" cy="360000"/>
+          </a:xfrm>
+          <a:prstGeom prst="rect">
+            <a:avLst/>
+          </a:prstGeom>
+          <a:noFill/>
+          <a:ln>
+            <a:noFill/>
+          </a:ln>
+        </p:spPr>
+        <p:txBody>
+          <a:bodyPr wrap="square" lIns="0" tIns="0" rIns="0" bIns="0"/>
+          <a:lstStyle/>
+          <a:p>
+            <a:r>
+              <a:rPr lang="fr-FR" sz="1700">
                 <a:solidFill>
                   <a:srgbClr val="475569"/>
                 </a:solidFill>
               </a:rPr>
-              <a:t>Rendre le projet consultable par les autres machines</a:t>
-            </a:r>
-            <a:endParaRPr lang="fr-FR" sz="1900"/>
+              <a:t>Migration vers une orchestration locale</a:t>
+            </a:r>
+            <a:endParaRPr lang="fr-FR" sz="1700"/>
           </a:p>
         </p:txBody>
       </p:sp>
@@ -2412,74 +3569,74 @@
         </p:nvSpPr>
         <p:spPr>
           <a:xfrm>
-            <a:off x="780000" y="1720000"/>
-            <a:ext cx="10350000" cy="3300000"/>
-          </a:xfrm>
-          <a:prstGeom prst="rect">
-            <a:avLst/>
-          </a:prstGeom>
-          <a:noFill/>
-          <a:ln>
-            <a:noFill/>
-          </a:ln>
-        </p:spPr>
-        <p:txBody>
-          <a:bodyPr wrap="square" lIns="0" tIns="0" rIns="0" bIns="0"/>
-          <a:lstStyle/>
-          <a:p>
-            <a:r>
-              <a:rPr lang="fr-FR" sz="2300">
+            <a:off x="780000" y="1580000"/>
+            <a:ext cx="10350000" cy="3200000"/>
+          </a:xfrm>
+          <a:prstGeom prst="rect">
+            <a:avLst/>
+          </a:prstGeom>
+          <a:noFill/>
+          <a:ln>
+            <a:noFill/>
+          </a:ln>
+        </p:spPr>
+        <p:txBody>
+          <a:bodyPr wrap="square" lIns="0" tIns="0" rIns="0" bIns="0"/>
+          <a:lstStyle/>
+          <a:p>
+            <a:r>
+              <a:rPr lang="fr-FR" sz="2250">
                 <a:solidFill>
                   <a:srgbClr val="1F2937"/>
                 </a:solidFill>
               </a:rPr>
-              <a:t>- Application : http://IP_MACHINE:8080</a:t>
-            </a:r>
-            <a:endParaRPr lang="fr-FR" sz="2300"/>
-          </a:p>
-          <a:p>
-            <a:r>
-              <a:rPr lang="fr-FR" sz="2300">
+              <a:t>- Namespace greenops dedie</a:t>
+            </a:r>
+            <a:endParaRPr lang="fr-FR" sz="2250"/>
+          </a:p>
+          <a:p>
+            <a:r>
+              <a:rPr lang="fr-FR" sz="2250">
                 <a:solidFill>
                   <a:srgbClr val="1F2937"/>
                 </a:solidFill>
               </a:rPr>
-              <a:t>- Grafana : http://IP_MACHINE:3001</a:t>
-            </a:r>
-            <a:endParaRPr lang="fr-FR" sz="2300"/>
-          </a:p>
-          <a:p>
-            <a:r>
-              <a:rPr lang="fr-FR" sz="2300">
+              <a:t>- Deployments et Services pour chaque composant</a:t>
+            </a:r>
+            <a:endParaRPr lang="fr-FR" sz="2250"/>
+          </a:p>
+          <a:p>
+            <a:r>
+              <a:rPr lang="fr-FR" sz="2250">
                 <a:solidFill>
                   <a:srgbClr val="1F2937"/>
                 </a:solidFill>
               </a:rPr>
-              <a:t>- Prometheus : http://IP_MACHINE:9090</a:t>
-            </a:r>
-            <a:endParaRPr lang="fr-FR" sz="2300"/>
-          </a:p>
-          <a:p>
-            <a:r>
-              <a:rPr lang="fr-FR" sz="2300">
+              <a:t>- Secrets et ConfigMaps pour la configuration</a:t>
+            </a:r>
+            <a:endParaRPr lang="fr-FR" sz="2250"/>
+          </a:p>
+          <a:p>
+            <a:r>
+              <a:rPr lang="fr-FR" sz="2250">
                 <a:solidFill>
                   <a:srgbClr val="1F2937"/>
                 </a:solidFill>
               </a:rPr>
-              <a:t>- Ouverture des ports dans le pare-feu Windows si besoin</a:t>
-            </a:r>
-            <a:endParaRPr lang="fr-FR" sz="2300"/>
-          </a:p>
-          <a:p>
-            <a:r>
-              <a:rPr lang="fr-FR" sz="2300">
+              <a:t>- PVC pour PostgreSQL, Prometheus et Grafana</a:t>
+            </a:r>
+            <a:endParaRPr lang="fr-FR" sz="2250"/>
+          </a:p>
+          <a:p>
+            <a:r>
+              <a:rPr lang="fr-FR" sz="2250">
                 <a:solidFill>
                   <a:srgbClr val="1F2937"/>
                 </a:solidFill>
               </a:rPr>
-              <a:t>- Port-forward Kubernetes possible avec --address 0.0.0.0</a:t>
-            </a:r>
-            <a:endParaRPr lang="fr-FR" sz="2300"/>
+              <a:t>- Probes, HPA et NetworkPolicies pour une approche professionnelle</a:t>
+            </a:r>
+            <a:endParaRPr lang="fr-FR" sz="2250"/>
           </a:p>
         </p:txBody>
       </p:sp>
@@ -2492,7 +3649,7 @@
         <p:spPr>
           <a:xfrm>
             <a:off x="780000" y="6500000"/>
-            <a:ext cx="8200000" cy="250000"/>
+            <a:ext cx="8800000" cy="250000"/>
           </a:xfrm>
           <a:prstGeom prst="rect">
             <a:avLst/>
@@ -2512,7 +3669,7 @@
                   <a:srgbClr val="64748B"/>
                 </a:solidFill>
               </a:rPr>
-              <a:t>Une autre machine doit utiliser l IP du PC, pas localhost</a:t>
+              <a:t>Kubernetes montre resilience, scaling et organisation</a:t>
             </a:r>
             <a:endParaRPr lang="fr-FR" sz="1250"/>
           </a:p>
@@ -2565,11 +3722,11 @@
             <a:avLst/>
           </a:prstGeom>
           <a:solidFill>
-            <a:srgbClr val="DC2626"/>
+            <a:srgbClr val="7C3AED"/>
           </a:solidFill>
           <a:ln w="14000">
             <a:solidFill>
-              <a:srgbClr val="DC2626"/>
+              <a:srgbClr val="7C3AED"/>
             </a:solidFill>
           </a:ln>
         </p:spPr>
@@ -2586,7 +3743,7 @@
         </p:nvSpPr>
         <p:spPr>
           <a:xfrm>
-            <a:off x="600000" y="380000"/>
+            <a:off x="600000" y="320000"/>
             <a:ext cx="10800000" cy="620000"/>
           </a:xfrm>
           <a:prstGeom prst="rect">
@@ -2602,14 +3759,14 @@
           <a:lstStyle/>
           <a:p>
             <a:r>
-              <a:rPr lang="fr-FR" sz="3800" b="1">
+              <a:rPr lang="fr-FR" sz="3600" b="1">
                 <a:solidFill>
                   <a:srgbClr val="0F172A"/>
                 </a:solidFill>
               </a:rPr>
-              <a:t>Tests de demonstration</a:t>
-            </a:r>
-            <a:endParaRPr lang="fr-FR" sz="3800"/>
+              <a:t>Preuve Kubernetes</a:t>
+            </a:r>
+            <a:endParaRPr lang="fr-FR" sz="3600"/>
           </a:p>
         </p:txBody>
       </p:sp>
@@ -2621,112 +3778,60 @@
         </p:nvSpPr>
         <p:spPr>
           <a:xfrm>
-            <a:off x="620000" y="1010000"/>
-            <a:ext cx="10300000" cy="420000"/>
-          </a:xfrm>
-          <a:prstGeom prst="rect">
-            <a:avLst/>
-          </a:prstGeom>
-          <a:noFill/>
-          <a:ln>
-            <a:noFill/>
-          </a:ln>
-        </p:spPr>
-        <p:txBody>
-          <a:bodyPr wrap="square" lIns="0" tIns="0" rIns="0" bIns="0"/>
-          <a:lstStyle/>
-          <a:p>
-            <a:r>
-              <a:rPr lang="fr-FR" sz="1900">
+            <a:off x="620000" y="930000"/>
+            <a:ext cx="10300000" cy="360000"/>
+          </a:xfrm>
+          <a:prstGeom prst="rect">
+            <a:avLst/>
+          </a:prstGeom>
+          <a:noFill/>
+          <a:ln>
+            <a:noFill/>
+          </a:ln>
+        </p:spPr>
+        <p:txBody>
+          <a:bodyPr wrap="square" lIns="0" tIns="0" rIns="0" bIns="0"/>
+          <a:lstStyle/>
+          <a:p>
+            <a:r>
+              <a:rPr lang="fr-FR" sz="1700">
                 <a:solidFill>
                   <a:srgbClr val="475569"/>
                 </a:solidFill>
               </a:rPr>
-              <a:t>Commandes simples a montrer</a:t>
-            </a:r>
-            <a:endParaRPr lang="fr-FR" sz="1900"/>
-          </a:p>
-        </p:txBody>
-      </p:sp>
-      <p:sp>
-        <p:nvSpPr>
-          <p:cNvPr id="13" name="Bullets"/>
-          <p:cNvSpPr txBox="1"/>
-          <p:nvPr/>
-        </p:nvSpPr>
-        <p:spPr>
-          <a:xfrm>
-            <a:off x="780000" y="1720000"/>
-            <a:ext cx="10350000" cy="3300000"/>
-          </a:xfrm>
-          <a:prstGeom prst="rect">
-            <a:avLst/>
-          </a:prstGeom>
-          <a:noFill/>
-          <a:ln>
-            <a:noFill/>
-          </a:ln>
-        </p:spPr>
-        <p:txBody>
-          <a:bodyPr wrap="square" lIns="0" tIns="0" rIns="0" bIns="0"/>
-          <a:lstStyle/>
-          <a:p>
-            <a:r>
-              <a:rPr lang="fr-FR" sz="2300">
-                <a:solidFill>
-                  <a:srgbClr val="1F2937"/>
-                </a:solidFill>
-              </a:rPr>
-              <a:t>- docker compose ps pour voir les conteneurs</a:t>
-            </a:r>
-            <a:endParaRPr lang="fr-FR" sz="2300"/>
-          </a:p>
-          <a:p>
-            <a:r>
-              <a:rPr lang="fr-FR" sz="2300">
-                <a:solidFill>
-                  <a:srgbClr val="1F2937"/>
-                </a:solidFill>
-              </a:rPr>
-              <a:t>- kubectl get pods -n greenops pour voir les pods</a:t>
-            </a:r>
-            <a:endParaRPr lang="fr-FR" sz="2300"/>
-          </a:p>
-          <a:p>
-            <a:r>
-              <a:rPr lang="fr-FR" sz="2300">
-                <a:solidFill>
-                  <a:srgbClr val="1F2937"/>
-                </a:solidFill>
-              </a:rPr>
-              <a:t>- /api/health pour verifier le gateway</a:t>
-            </a:r>
-            <a:endParaRPr lang="fr-FR" sz="2300"/>
-          </a:p>
-          <a:p>
-            <a:r>
-              <a:rPr lang="fr-FR" sz="2300">
-                <a:solidFill>
-                  <a:srgbClr val="1F2937"/>
-                </a:solidFill>
-              </a:rPr>
-              <a:t>- /api/energy/summary pour verifier le service metier</a:t>
-            </a:r>
-            <a:endParaRPr lang="fr-FR" sz="2300"/>
-          </a:p>
-          <a:p>
-            <a:r>
-              <a:rPr lang="fr-FR" sz="2300">
-                <a:solidFill>
-                  <a:srgbClr val="1F2937"/>
-                </a:solidFill>
-              </a:rPr>
-              <a:t>- Suppression d un pod pour montrer la resilience Kubernetes</a:t>
-            </a:r>
-            <a:endParaRPr lang="fr-FR" sz="2300"/>
-          </a:p>
-        </p:txBody>
-      </p:sp>
+              <a:t>Pods et deploiements actifs dans le namespace greenops</a:t>
+            </a:r>
+            <a:endParaRPr lang="fr-FR" sz="1700"/>
+          </a:p>
+        </p:txBody>
+      </p:sp>
+      <p:pic>
+        <p:nvPicPr>
+          <p:cNvPr id="13" name="Proof image"/>
+          <p:cNvPicPr/>
+          <p:nvPr/>
+        </p:nvPicPr>
+        <p:blipFill>
+          <a:blip r:embed="rId2"/>
+          <a:stretch>
+            <a:fillRect/>
+          </a:stretch>
+        </p:blipFill>
+        <p:spPr>
+          <a:xfrm>
+            <a:off x="1650000" y="1400000"/>
+            <a:ext cx="8890000" cy="5000000"/>
+          </a:xfrm>
+          <a:prstGeom prst="rect">
+            <a:avLst/>
+          </a:prstGeom>
+          <a:ln w="18000">
+            <a:solidFill>
+              <a:srgbClr val="CBD5E1"/>
+            </a:solidFill>
+          </a:ln>
+        </p:spPr>
+      </p:pic>
       <p:sp>
         <p:nvSpPr>
           <p:cNvPr id="15" name="Footer"/>
@@ -2736,7 +3841,7 @@
         <p:spPr>
           <a:xfrm>
             <a:off x="780000" y="6500000"/>
-            <a:ext cx="8200000" cy="250000"/>
+            <a:ext cx="8800000" cy="250000"/>
           </a:xfrm>
           <a:prstGeom prst="rect">
             <a:avLst/>
@@ -2756,7 +3861,7 @@
                   <a:srgbClr val="64748B"/>
                 </a:solidFill>
               </a:rPr>
-              <a:t>Les tests prouvent que la plateforme fonctionne</a:t>
+              <a:t>Capture de commande : kubectl get pods/deploy -n greenops</a:t>
             </a:r>
             <a:endParaRPr lang="fr-FR" sz="1250"/>
           </a:p>

</xml_diff>